<commit_message>
Slides carry only the lesson (ruling 37, widened): no box, no grey text; figures checked (ruling 38); console right on tablets — Units 3 and 4 rebuilt on kit 833f5d0
Co-Authored-By: Claude Opus 5.5 <noreply@anthropic.com>
Claude-Session: https://claude.ai/code/session_015xYWeLUsuszQH6z7ADE9tj
</commit_message>
<xml_diff>
--- a/a7/build/out/u3/A7 3.05 Applying Exponent Laws - Slides.pptx
+++ b/a7/build/out/u3/A7 3.05 Applying Exponent Laws - Slides.pptx
@@ -3129,7 +3129,7 @@
         </p:nvSpPr>
         <p:spPr>
           <a:xfrm>
-            <a:off x="777240" y="1691640"/>
+            <a:off x="777240" y="2148840"/>
             <a:ext cx="10607040" cy="347472"/>
           </a:xfrm>
           <a:prstGeom prst="rect">
@@ -3164,7 +3164,7 @@
         </p:nvSpPr>
         <p:spPr>
           <a:xfrm>
-            <a:off x="777240" y="2048256"/>
+            <a:off x="777240" y="2505456"/>
             <a:ext cx="10607040" cy="1005840"/>
           </a:xfrm>
           <a:prstGeom prst="rect">
@@ -3199,7 +3199,7 @@
         </p:nvCxnSpPr>
         <p:spPr>
           <a:xfrm>
-            <a:off x="3291840" y="3255264"/>
+            <a:off x="3291840" y="3712464"/>
             <a:ext cx="5577840" cy="0"/>
           </a:xfrm>
           <a:prstGeom prst="line">
@@ -3234,7 +3234,7 @@
         </p:nvCxnSpPr>
         <p:spPr>
           <a:xfrm>
-            <a:off x="3291840" y="3337560"/>
+            <a:off x="3291840" y="3794760"/>
             <a:ext cx="5577840" cy="0"/>
           </a:xfrm>
           <a:prstGeom prst="line">
@@ -3269,7 +3269,7 @@
         </p:nvSpPr>
         <p:spPr>
           <a:xfrm>
-            <a:off x="777240" y="3502152"/>
+            <a:off x="777240" y="3959352"/>
             <a:ext cx="10607040" cy="310896"/>
           </a:xfrm>
           <a:prstGeom prst="rect">
@@ -3304,7 +3304,7 @@
         </p:nvSpPr>
         <p:spPr>
           <a:xfrm>
-            <a:off x="777240" y="3840480"/>
+            <a:off x="777240" y="4297680"/>
             <a:ext cx="10607040" cy="731520"/>
           </a:xfrm>
           <a:prstGeom prst="rect">
@@ -3327,129 +3327,13 @@
                 <a:latin typeface="Century Schoolbook"/>
               </a:rPr>
               <a:t>I can rewrite a rational base with a negative exponent using a positive exponent, and apply several laws to generate an equivalent expression.</a:t>
-            </a:r>
-          </a:p>
-        </p:txBody>
-      </p:sp>
-      <p:sp>
-        <p:nvSpPr>
-          <p:cNvPr id="8" name="Rectangle 7"/>
-          <p:cNvSpPr/>
-          <p:nvPr/>
-        </p:nvSpPr>
-        <p:spPr>
-          <a:xfrm>
-            <a:off x="2377440" y="4736592"/>
-            <a:ext cx="7406640" cy="1051560"/>
-          </a:xfrm>
-          <a:prstGeom prst="rect">
-            <a:avLst/>
-          </a:prstGeom>
-          <a:solidFill>
-            <a:srgbClr val="F2F2F0"/>
-          </a:solidFill>
-          <a:ln w="9525">
-            <a:solidFill>
-              <a:srgbClr val="BFBFBF"/>
-            </a:solidFill>
-          </a:ln>
-          <a:effectLst/>
-        </p:spPr>
-        <p:style>
-          <a:lnRef idx="1">
-            <a:schemeClr val="accent1"/>
-          </a:lnRef>
-          <a:fillRef idx="3">
-            <a:schemeClr val="accent1"/>
-          </a:fillRef>
-          <a:effectRef idx="2">
-            <a:schemeClr val="accent1"/>
-          </a:effectRef>
-          <a:fontRef idx="minor">
-            <a:schemeClr val="lt1"/>
-          </a:fontRef>
-        </p:style>
-        <p:txBody>
-          <a:bodyPr rtlCol="0" anchor="ctr"/>
-          <a:lstStyle/>
-          <a:p>
-            <a:pPr algn="ctr"/>
-          </a:p>
-        </p:txBody>
-      </p:sp>
-      <p:sp>
-        <p:nvSpPr>
-          <p:cNvPr id="9" name="TextBox 8"/>
-          <p:cNvSpPr txBox="1"/>
-          <p:nvPr/>
-        </p:nvSpPr>
-        <p:spPr>
-          <a:xfrm>
-            <a:off x="2606040" y="4892040"/>
-            <a:ext cx="6949440" cy="365760"/>
-          </a:xfrm>
-          <a:prstGeom prst="rect">
-            <a:avLst/>
-          </a:prstGeom>
-          <a:noFill/>
-        </p:spPr>
-        <p:txBody>
-          <a:bodyPr wrap="square" lIns="45720" rIns="45720" tIns="18288" bIns="18288" anchor="t">
-            <a:spAutoFit/>
-          </a:bodyPr>
-          <a:lstStyle/>
-          <a:p>
-            <a:pPr algn="ctr"/>
-            <a:r>
-              <a:rPr sz="1700" b="0" i="1">
-                <a:solidFill>
-                  <a:srgbClr val="6B6B6B"/>
-                </a:solidFill>
-                <a:latin typeface="Century Schoolbook"/>
-              </a:rPr>
-              <a:t>Yesterday: a negative exponent means reciprocal.</a:t>
-            </a:r>
-          </a:p>
-        </p:txBody>
-      </p:sp>
-      <p:sp>
-        <p:nvSpPr>
-          <p:cNvPr id="10" name="TextBox 9"/>
-          <p:cNvSpPr txBox="1"/>
-          <p:nvPr/>
-        </p:nvSpPr>
-        <p:spPr>
-          <a:xfrm>
-            <a:off x="2606040" y="5276088"/>
-            <a:ext cx="6949440" cy="365760"/>
-          </a:xfrm>
-          <a:prstGeom prst="rect">
-            <a:avLst/>
-          </a:prstGeom>
-          <a:noFill/>
-        </p:spPr>
-        <p:txBody>
-          <a:bodyPr wrap="square" lIns="45720" rIns="45720" tIns="18288" bIns="18288" anchor="t">
-            <a:spAutoFit/>
-          </a:bodyPr>
-          <a:lstStyle/>
-          <a:p>
-            <a:pPr algn="ctr"/>
-            <a:r>
-              <a:rPr sz="1700" b="1" i="0">
-                <a:solidFill>
-                  <a:srgbClr val="1A1A1A"/>
-                </a:solidFill>
-                <a:latin typeface="Century Schoolbook"/>
-              </a:rPr>
-              <a:t>Today the base is a fraction — so the reciprocal flips it.</a:t>
             </a:r>
           </a:p>
         </p:txBody>
       </p:sp>
       <p:cxnSp>
         <p:nvCxnSpPr>
-          <p:cNvPr id="11" name="Connector 10"/>
+          <p:cNvPr id="8" name="Connector 7"/>
           <p:cNvCxnSpPr/>
           <p:nvPr/>
         </p:nvCxnSpPr>
@@ -3484,7 +3368,7 @@
       </p:cxnSp>
       <p:sp>
         <p:nvSpPr>
-          <p:cNvPr id="12" name="TextBox 11"/>
+          <p:cNvPr id="9" name="TextBox 8"/>
           <p:cNvSpPr txBox="1"/>
           <p:nvPr/>
         </p:nvSpPr>
@@ -3519,7 +3403,7 @@
       </p:sp>
       <p:sp>
         <p:nvSpPr>
-          <p:cNvPr id="13" name="TextBox 12"/>
+          <p:cNvPr id="10" name="TextBox 9"/>
           <p:cNvSpPr txBox="1"/>
           <p:nvPr/>
         </p:nvSpPr>
@@ -3675,44 +3559,9 @@
           </a:fontRef>
         </p:style>
       </p:cxnSp>
-      <p:sp>
-        <p:nvSpPr>
-          <p:cNvPr id="5" name="TextBox 4"/>
-          <p:cNvSpPr txBox="1"/>
-          <p:nvPr/>
-        </p:nvSpPr>
-        <p:spPr>
-          <a:xfrm>
-            <a:off x="777240" y="1261872"/>
-            <a:ext cx="10607040" cy="310896"/>
-          </a:xfrm>
-          <a:prstGeom prst="rect">
-            <a:avLst/>
-          </a:prstGeom>
-          <a:noFill/>
-        </p:spPr>
-        <p:txBody>
-          <a:bodyPr wrap="square" lIns="45720" rIns="45720" tIns="18288" bIns="18288" anchor="t">
-            <a:spAutoFit/>
-          </a:bodyPr>
-          <a:lstStyle/>
-          <a:p>
-            <a:pPr algn="l"/>
-            <a:r>
-              <a:rPr sz="1700" b="0" i="1">
-                <a:solidFill>
-                  <a:srgbClr val="6B6B6B"/>
-                </a:solidFill>
-                <a:latin typeface="Century Schoolbook"/>
-              </a:rPr>
-              <a:t>Answer.</a:t>
-            </a:r>
-          </a:p>
-        </p:txBody>
-      </p:sp>
       <p:cxnSp>
         <p:nvCxnSpPr>
-          <p:cNvPr id="6" name="Connector 5"/>
+          <p:cNvPr id="5" name="Connector 4"/>
           <p:cNvCxnSpPr/>
           <p:nvPr/>
         </p:nvCxnSpPr>
@@ -3747,7 +3596,7 @@
       </p:cxnSp>
       <p:sp>
         <p:nvSpPr>
-          <p:cNvPr id="7" name="TextBox 6"/>
+          <p:cNvPr id="6" name="TextBox 5"/>
           <p:cNvSpPr txBox="1"/>
           <p:nvPr/>
         </p:nvSpPr>
@@ -3782,7 +3631,7 @@
       </p:sp>
       <p:sp>
         <p:nvSpPr>
-          <p:cNvPr id="8" name="TextBox 7"/>
+          <p:cNvPr id="7" name="TextBox 6"/>
           <p:cNvSpPr txBox="1"/>
           <p:nvPr/>
         </p:nvSpPr>
@@ -3817,7 +3666,7 @@
       </p:sp>
       <p:pic>
         <p:nvPicPr>
-          <p:cNvPr id="9" name="Picture 8" descr="055ea4267017cf05.png"/>
+          <p:cNvPr id="8" name="Picture 7" descr="055ea4267017cf05.png"/>
           <p:cNvPicPr>
             <a:picLocks noChangeAspect="1"/>
           </p:cNvPicPr>
@@ -3841,60 +3690,42 @@
       </p:pic>
       <p:sp>
         <p:nvSpPr>
+          <p:cNvPr id="9" name="TextBox 8"/>
+          <p:cNvSpPr txBox="1"/>
+          <p:nvPr/>
+        </p:nvSpPr>
+        <p:spPr>
+          <a:xfrm>
+            <a:off x="777240" y="3560064"/>
+            <a:ext cx="10607040" cy="429370"/>
+          </a:xfrm>
+          <a:prstGeom prst="rect">
+            <a:avLst/>
+          </a:prstGeom>
+          <a:noFill/>
+        </p:spPr>
+        <p:txBody>
+          <a:bodyPr wrap="square" lIns="45720" rIns="45720" tIns="18288" bIns="18288" anchor="t">
+            <a:spAutoFit/>
+          </a:bodyPr>
+          <a:lstStyle/>
+          <a:p>
+            <a:pPr algn="ctr"/>
+            <a:r>
+              <a:rPr sz="2400" b="1" i="0">
+                <a:solidFill>
+                  <a:srgbClr val="1A1A1A"/>
+                </a:solidFill>
+                <a:latin typeface="Century Schoolbook"/>
+              </a:rPr>
+              <a:t>Rewrite with a positive exponent, then find the value.</a:t>
+            </a:r>
+          </a:p>
+        </p:txBody>
+      </p:sp>
+      <p:sp>
+        <p:nvSpPr>
           <p:cNvPr id="10" name="TextBox 9"/>
-          <p:cNvSpPr txBox="1"/>
-          <p:nvPr/>
-        </p:nvSpPr>
-        <p:spPr>
-          <a:xfrm>
-            <a:off x="777240" y="3377184"/>
-            <a:ext cx="10607040" cy="429370"/>
-          </a:xfrm>
-          <a:prstGeom prst="rect">
-            <a:avLst/>
-          </a:prstGeom>
-          <a:noFill/>
-        </p:spPr>
-        <p:txBody>
-          <a:bodyPr wrap="square" lIns="45720" rIns="45720" tIns="18288" bIns="18288" anchor="t">
-            <a:spAutoFit/>
-          </a:bodyPr>
-          <a:lstStyle/>
-          <a:p>
-            <a:pPr algn="ctr"/>
-            <a:r>
-              <a:rPr sz="2400" b="0" i="0">
-                <a:solidFill>
-                  <a:srgbClr val="6B6B6B"/>
-                </a:solidFill>
-                <a:latin typeface="Century Schoolbook"/>
-              </a:rPr>
-              <a:t>(−2/5)</a:t>
-            </a:r>
-            <a:r>
-              <a:rPr sz="2400" b="0" i="0" baseline="30000">
-                <a:solidFill>
-                  <a:srgbClr val="6B6B6B"/>
-                </a:solidFill>
-                <a:latin typeface="Century Schoolbook"/>
-              </a:rPr>
-              <a:t>3</a:t>
-            </a:r>
-            <a:r>
-              <a:rPr sz="2400" b="0" i="0">
-                <a:solidFill>
-                  <a:srgbClr val="6B6B6B"/>
-                </a:solidFill>
-                <a:latin typeface="Century Schoolbook"/>
-              </a:rPr>
-              <a:t> — odd power, negative</a:t>
-            </a:r>
-          </a:p>
-        </p:txBody>
-      </p:sp>
-      <p:sp>
-        <p:nvSpPr>
-          <p:cNvPr id="11" name="TextBox 10"/>
           <p:cNvSpPr txBox="1"/>
           <p:nvPr/>
         </p:nvSpPr>
@@ -3929,7 +3760,7 @@
       </p:sp>
       <p:pic>
         <p:nvPicPr>
-          <p:cNvPr id="12" name="Picture 11" descr="cacffea294d43135.png"/>
+          <p:cNvPr id="11" name="Picture 10" descr="cacffea294d43135.png"/>
           <p:cNvPicPr>
             <a:picLocks noChangeAspect="1"/>
           </p:cNvPicPr>
@@ -4074,44 +3905,9 @@
           </a:fontRef>
         </p:style>
       </p:cxnSp>
-      <p:sp>
-        <p:nvSpPr>
-          <p:cNvPr id="5" name="TextBox 4"/>
-          <p:cNvSpPr txBox="1"/>
-          <p:nvPr/>
-        </p:nvSpPr>
-        <p:spPr>
-          <a:xfrm>
-            <a:off x="777240" y="1261872"/>
-            <a:ext cx="10607040" cy="310896"/>
-          </a:xfrm>
-          <a:prstGeom prst="rect">
-            <a:avLst/>
-          </a:prstGeom>
-          <a:noFill/>
-        </p:spPr>
-        <p:txBody>
-          <a:bodyPr wrap="square" lIns="45720" rIns="45720" tIns="18288" bIns="18288" anchor="t">
-            <a:spAutoFit/>
-          </a:bodyPr>
-          <a:lstStyle/>
-          <a:p>
-            <a:pPr algn="l"/>
-            <a:r>
-              <a:rPr sz="1700" b="0" i="1">
-                <a:solidFill>
-                  <a:srgbClr val="6B6B6B"/>
-                </a:solidFill>
-                <a:latin typeface="Century Schoolbook"/>
-              </a:rPr>
-              <a:t>Two laws, then a flip.</a:t>
-            </a:r>
-          </a:p>
-        </p:txBody>
-      </p:sp>
       <p:cxnSp>
         <p:nvCxnSpPr>
-          <p:cNvPr id="6" name="Connector 5"/>
+          <p:cNvPr id="5" name="Connector 4"/>
           <p:cNvCxnSpPr/>
           <p:nvPr/>
         </p:nvCxnSpPr>
@@ -4146,7 +3942,7 @@
       </p:cxnSp>
       <p:sp>
         <p:nvSpPr>
-          <p:cNvPr id="7" name="TextBox 6"/>
+          <p:cNvPr id="6" name="TextBox 5"/>
           <p:cNvSpPr txBox="1"/>
           <p:nvPr/>
         </p:nvSpPr>
@@ -4181,7 +3977,7 @@
       </p:sp>
       <p:sp>
         <p:nvSpPr>
-          <p:cNvPr id="8" name="TextBox 7"/>
+          <p:cNvPr id="7" name="TextBox 6"/>
           <p:cNvSpPr txBox="1"/>
           <p:nvPr/>
         </p:nvSpPr>
@@ -4216,7 +4012,7 @@
       </p:sp>
       <p:pic>
         <p:nvPicPr>
-          <p:cNvPr id="9" name="Picture 8" descr="b8ecac4debf08671.png"/>
+          <p:cNvPr id="8" name="Picture 7" descr="b8ecac4debf08671.png"/>
           <p:cNvPicPr>
             <a:picLocks noChangeAspect="1"/>
           </p:cNvPicPr>
@@ -4240,7 +4036,7 @@
       </p:pic>
       <p:sp>
         <p:nvSpPr>
-          <p:cNvPr id="10" name="TextBox 9"/>
+          <p:cNvPr id="9" name="TextBox 8"/>
           <p:cNvSpPr txBox="1"/>
           <p:nvPr/>
         </p:nvSpPr>
@@ -4396,44 +4192,9 @@
           </a:fontRef>
         </p:style>
       </p:cxnSp>
-      <p:sp>
-        <p:nvSpPr>
-          <p:cNvPr id="5" name="TextBox 4"/>
-          <p:cNvSpPr txBox="1"/>
-          <p:nvPr/>
-        </p:nvSpPr>
-        <p:spPr>
-          <a:xfrm>
-            <a:off x="777240" y="1261872"/>
-            <a:ext cx="10607040" cy="310896"/>
-          </a:xfrm>
-          <a:prstGeom prst="rect">
-            <a:avLst/>
-          </a:prstGeom>
-          <a:noFill/>
-        </p:spPr>
-        <p:txBody>
-          <a:bodyPr wrap="square" lIns="45720" rIns="45720" tIns="18288" bIns="18288" anchor="t">
-            <a:spAutoFit/>
-          </a:bodyPr>
-          <a:lstStyle/>
-          <a:p>
-            <a:pPr algn="l"/>
-            <a:r>
-              <a:rPr sz="1700" b="0" i="1">
-                <a:solidFill>
-                  <a:srgbClr val="6B6B6B"/>
-                </a:solidFill>
-                <a:latin typeface="Century Schoolbook"/>
-              </a:rPr>
-              <a:t>Worked.</a:t>
-            </a:r>
-          </a:p>
-        </p:txBody>
-      </p:sp>
       <p:cxnSp>
         <p:nvCxnSpPr>
-          <p:cNvPr id="6" name="Connector 5"/>
+          <p:cNvPr id="5" name="Connector 4"/>
           <p:cNvCxnSpPr/>
           <p:nvPr/>
         </p:nvCxnSpPr>
@@ -4468,7 +4229,7 @@
       </p:cxnSp>
       <p:sp>
         <p:nvSpPr>
-          <p:cNvPr id="7" name="TextBox 6"/>
+          <p:cNvPr id="6" name="TextBox 5"/>
           <p:cNvSpPr txBox="1"/>
           <p:nvPr/>
         </p:nvSpPr>
@@ -4503,7 +4264,7 @@
       </p:sp>
       <p:sp>
         <p:nvSpPr>
-          <p:cNvPr id="8" name="TextBox 7"/>
+          <p:cNvPr id="7" name="TextBox 6"/>
           <p:cNvSpPr txBox="1"/>
           <p:nvPr/>
         </p:nvSpPr>
@@ -4538,7 +4299,7 @@
       </p:sp>
       <p:pic>
         <p:nvPicPr>
-          <p:cNvPr id="9" name="Picture 8" descr="10be869d41e0dd57.png"/>
+          <p:cNvPr id="8" name="Picture 7" descr="10be869d41e0dd57.png"/>
           <p:cNvPicPr>
             <a:picLocks noChangeAspect="1"/>
           </p:cNvPicPr>
@@ -4560,44 +4321,9 @@
           </a:prstGeom>
         </p:spPr>
       </p:pic>
-      <p:sp>
-        <p:nvSpPr>
-          <p:cNvPr id="10" name="TextBox 9"/>
-          <p:cNvSpPr txBox="1"/>
-          <p:nvPr/>
-        </p:nvSpPr>
-        <p:spPr>
-          <a:xfrm>
-            <a:off x="7525512" y="2039112"/>
-            <a:ext cx="3858767" cy="502920"/>
-          </a:xfrm>
-          <a:prstGeom prst="rect">
-            <a:avLst/>
-          </a:prstGeom>
-          <a:noFill/>
-        </p:spPr>
-        <p:txBody>
-          <a:bodyPr wrap="square" lIns="45720" rIns="45720" tIns="18288" bIns="18288" anchor="ctr">
-            <a:spAutoFit/>
-          </a:bodyPr>
-          <a:lstStyle/>
-          <a:p>
-            <a:pPr algn="l"/>
-            <a:r>
-              <a:rPr sz="2100" b="0" i="1">
-                <a:solidFill>
-                  <a:srgbClr val="6B6B6B"/>
-                </a:solidFill>
-                <a:latin typeface="Century Schoolbook"/>
-              </a:rPr>
-              <a:t>product of powers</a:t>
-            </a:r>
-          </a:p>
-        </p:txBody>
-      </p:sp>
       <p:pic>
         <p:nvPicPr>
-          <p:cNvPr id="11" name="Picture 10" descr="268771bcd93959c7.png"/>
+          <p:cNvPr id="9" name="Picture 8" descr="268771bcd93959c7.png"/>
           <p:cNvPicPr>
             <a:picLocks noChangeAspect="1"/>
           </p:cNvPicPr>
@@ -4621,42 +4347,7 @@
       </p:pic>
       <p:sp>
         <p:nvSpPr>
-          <p:cNvPr id="12" name="TextBox 11"/>
-          <p:cNvSpPr txBox="1"/>
-          <p:nvPr/>
-        </p:nvSpPr>
-        <p:spPr>
-          <a:xfrm>
-            <a:off x="3907536" y="3008376"/>
-            <a:ext cx="6400800" cy="502920"/>
-          </a:xfrm>
-          <a:prstGeom prst="rect">
-            <a:avLst/>
-          </a:prstGeom>
-          <a:noFill/>
-        </p:spPr>
-        <p:txBody>
-          <a:bodyPr wrap="square" lIns="45720" rIns="45720" tIns="18288" bIns="18288" anchor="ctr">
-            <a:spAutoFit/>
-          </a:bodyPr>
-          <a:lstStyle/>
-          <a:p>
-            <a:pPr algn="l"/>
-            <a:r>
-              <a:rPr sz="2100" b="0" i="1">
-                <a:solidFill>
-                  <a:srgbClr val="6B6B6B"/>
-                </a:solidFill>
-                <a:latin typeface="Century Schoolbook"/>
-              </a:rPr>
-              <a:t>already positive: no flip</a:t>
-            </a:r>
-          </a:p>
-        </p:txBody>
-      </p:sp>
-      <p:sp>
-        <p:nvSpPr>
-          <p:cNvPr id="13" name="TextBox 12"/>
+          <p:cNvPr id="10" name="TextBox 9"/>
           <p:cNvSpPr txBox="1"/>
           <p:nvPr/>
         </p:nvSpPr>
@@ -4830,44 +4521,9 @@
           </a:fontRef>
         </p:style>
       </p:cxnSp>
-      <p:sp>
-        <p:nvSpPr>
-          <p:cNvPr id="5" name="TextBox 4"/>
-          <p:cNvSpPr txBox="1"/>
-          <p:nvPr/>
-        </p:nvSpPr>
-        <p:spPr>
-          <a:xfrm>
-            <a:off x="777240" y="1261872"/>
-            <a:ext cx="10607040" cy="310896"/>
-          </a:xfrm>
-          <a:prstGeom prst="rect">
-            <a:avLst/>
-          </a:prstGeom>
-          <a:noFill/>
-        </p:spPr>
-        <p:txBody>
-          <a:bodyPr wrap="square" lIns="45720" rIns="45720" tIns="18288" bIns="18288" anchor="t">
-            <a:spAutoFit/>
-          </a:bodyPr>
-          <a:lstStyle/>
-          <a:p>
-            <a:pPr algn="l"/>
-            <a:r>
-              <a:rPr sz="1700" b="0" i="1">
-                <a:solidFill>
-                  <a:srgbClr val="6B6B6B"/>
-                </a:solidFill>
-                <a:latin typeface="Century Schoolbook"/>
-              </a:rPr>
-              <a:t>Same steps, your numbers. Boards up when done.</a:t>
-            </a:r>
-          </a:p>
-        </p:txBody>
-      </p:sp>
       <p:cxnSp>
         <p:nvCxnSpPr>
-          <p:cNvPr id="6" name="Connector 5"/>
+          <p:cNvPr id="5" name="Connector 4"/>
           <p:cNvCxnSpPr/>
           <p:nvPr/>
         </p:nvCxnSpPr>
@@ -4902,7 +4558,7 @@
       </p:cxnSp>
       <p:sp>
         <p:nvSpPr>
-          <p:cNvPr id="7" name="TextBox 6"/>
+          <p:cNvPr id="6" name="TextBox 5"/>
           <p:cNvSpPr txBox="1"/>
           <p:nvPr/>
         </p:nvSpPr>
@@ -4937,7 +4593,7 @@
       </p:sp>
       <p:sp>
         <p:nvSpPr>
-          <p:cNvPr id="8" name="TextBox 7"/>
+          <p:cNvPr id="7" name="TextBox 6"/>
           <p:cNvSpPr txBox="1"/>
           <p:nvPr/>
         </p:nvSpPr>
@@ -4972,7 +4628,7 @@
       </p:sp>
       <p:pic>
         <p:nvPicPr>
-          <p:cNvPr id="9" name="Picture 8" descr="a7f97d6945899edc.png"/>
+          <p:cNvPr id="8" name="Picture 7" descr="a7f97d6945899edc.png"/>
           <p:cNvPicPr>
             <a:picLocks noChangeAspect="1"/>
           </p:cNvPicPr>
@@ -4994,6 +4650,41 @@
           </a:prstGeom>
         </p:spPr>
       </p:pic>
+      <p:sp>
+        <p:nvSpPr>
+          <p:cNvPr id="9" name="TextBox 8"/>
+          <p:cNvSpPr txBox="1"/>
+          <p:nvPr/>
+        </p:nvSpPr>
+        <p:spPr>
+          <a:xfrm>
+            <a:off x="777240" y="3560064"/>
+            <a:ext cx="10607040" cy="858740"/>
+          </a:xfrm>
+          <a:prstGeom prst="rect">
+            <a:avLst/>
+          </a:prstGeom>
+          <a:noFill/>
+        </p:spPr>
+        <p:txBody>
+          <a:bodyPr wrap="square" lIns="45720" rIns="45720" tIns="18288" bIns="18288" anchor="t">
+            <a:spAutoFit/>
+          </a:bodyPr>
+          <a:lstStyle/>
+          <a:p>
+            <a:pPr algn="ctr"/>
+            <a:r>
+              <a:rPr sz="2400" b="1" i="0">
+                <a:solidFill>
+                  <a:srgbClr val="1A1A1A"/>
+                </a:solidFill>
+                <a:latin typeface="Century Schoolbook"/>
+              </a:rPr>
+              <a:t>Write an equivalent expression with one base and a positive exponent.</a:t>
+            </a:r>
+          </a:p>
+        </p:txBody>
+      </p:sp>
     </p:spTree>
   </p:cSld>
   <p:clrMapOvr>
@@ -5117,44 +4808,9 @@
           </a:fontRef>
         </p:style>
       </p:cxnSp>
-      <p:sp>
-        <p:nvSpPr>
-          <p:cNvPr id="5" name="TextBox 4"/>
-          <p:cNvSpPr txBox="1"/>
-          <p:nvPr/>
-        </p:nvSpPr>
-        <p:spPr>
-          <a:xfrm>
-            <a:off x="777240" y="1261872"/>
-            <a:ext cx="10607040" cy="310896"/>
-          </a:xfrm>
-          <a:prstGeom prst="rect">
-            <a:avLst/>
-          </a:prstGeom>
-          <a:noFill/>
-        </p:spPr>
-        <p:txBody>
-          <a:bodyPr wrap="square" lIns="45720" rIns="45720" tIns="18288" bIns="18288" anchor="t">
-            <a:spAutoFit/>
-          </a:bodyPr>
-          <a:lstStyle/>
-          <a:p>
-            <a:pPr algn="l"/>
-            <a:r>
-              <a:rPr sz="1700" b="0" i="1">
-                <a:solidFill>
-                  <a:srgbClr val="6B6B6B"/>
-                </a:solidFill>
-                <a:latin typeface="Century Schoolbook"/>
-              </a:rPr>
-              <a:t>Answer.</a:t>
-            </a:r>
-          </a:p>
-        </p:txBody>
-      </p:sp>
       <p:cxnSp>
         <p:nvCxnSpPr>
-          <p:cNvPr id="6" name="Connector 5"/>
+          <p:cNvPr id="5" name="Connector 4"/>
           <p:cNvCxnSpPr/>
           <p:nvPr/>
         </p:nvCxnSpPr>
@@ -5189,7 +4845,7 @@
       </p:cxnSp>
       <p:sp>
         <p:nvSpPr>
-          <p:cNvPr id="7" name="TextBox 6"/>
+          <p:cNvPr id="6" name="TextBox 5"/>
           <p:cNvSpPr txBox="1"/>
           <p:nvPr/>
         </p:nvSpPr>
@@ -5224,7 +4880,7 @@
       </p:sp>
       <p:sp>
         <p:nvSpPr>
-          <p:cNvPr id="8" name="TextBox 7"/>
+          <p:cNvPr id="7" name="TextBox 6"/>
           <p:cNvSpPr txBox="1"/>
           <p:nvPr/>
         </p:nvSpPr>
@@ -5259,7 +4915,7 @@
       </p:sp>
       <p:pic>
         <p:nvPicPr>
-          <p:cNvPr id="9" name="Picture 8" descr="40cdd198e5060778.png"/>
+          <p:cNvPr id="8" name="Picture 7" descr="40cdd198e5060778.png"/>
           <p:cNvPicPr>
             <a:picLocks noChangeAspect="1"/>
           </p:cNvPicPr>
@@ -5283,57 +4939,48 @@
       </p:pic>
       <p:sp>
         <p:nvSpPr>
+          <p:cNvPr id="9" name="TextBox 8"/>
+          <p:cNvSpPr txBox="1"/>
+          <p:nvPr/>
+        </p:nvSpPr>
+        <p:spPr>
+          <a:xfrm>
+            <a:off x="777240" y="3560064"/>
+            <a:ext cx="10607040" cy="858740"/>
+          </a:xfrm>
+          <a:prstGeom prst="rect">
+            <a:avLst/>
+          </a:prstGeom>
+          <a:noFill/>
+        </p:spPr>
+        <p:txBody>
+          <a:bodyPr wrap="square" lIns="45720" rIns="45720" tIns="18288" bIns="18288" anchor="t">
+            <a:spAutoFit/>
+          </a:bodyPr>
+          <a:lstStyle/>
+          <a:p>
+            <a:pPr algn="ctr"/>
+            <a:r>
+              <a:rPr sz="2400" b="1" i="0">
+                <a:solidFill>
+                  <a:srgbClr val="1A1A1A"/>
+                </a:solidFill>
+                <a:latin typeface="Century Schoolbook"/>
+              </a:rPr>
+              <a:t>Write an equivalent expression with one base and a positive exponent.</a:t>
+            </a:r>
+          </a:p>
+        </p:txBody>
+      </p:sp>
+      <p:sp>
+        <p:nvSpPr>
           <p:cNvPr id="10" name="TextBox 9"/>
           <p:cNvSpPr txBox="1"/>
           <p:nvPr/>
         </p:nvSpPr>
         <p:spPr>
           <a:xfrm>
-            <a:off x="777240" y="3377184"/>
-            <a:ext cx="10607040" cy="429370"/>
-          </a:xfrm>
-          <a:prstGeom prst="rect">
-            <a:avLst/>
-          </a:prstGeom>
-          <a:noFill/>
-        </p:spPr>
-        <p:txBody>
-          <a:bodyPr wrap="square" lIns="45720" rIns="45720" tIns="18288" bIns="18288" anchor="t">
-            <a:spAutoFit/>
-          </a:bodyPr>
-          <a:lstStyle/>
-          <a:p>
-            <a:pPr algn="ctr"/>
-            <a:r>
-              <a:rPr sz="2400" b="0" i="0">
-                <a:solidFill>
-                  <a:srgbClr val="6B6B6B"/>
-                </a:solidFill>
-                <a:latin typeface="Century Schoolbook"/>
-              </a:rPr>
-              <a:t>exponent −10, then flip: (−4/5)</a:t>
-            </a:r>
-            <a:r>
-              <a:rPr sz="2400" b="0" i="0" baseline="30000">
-                <a:solidFill>
-                  <a:srgbClr val="6B6B6B"/>
-                </a:solidFill>
-                <a:latin typeface="Century Schoolbook"/>
-              </a:rPr>
-              <a:t>10</a:t>
-            </a:r>
-          </a:p>
-        </p:txBody>
-      </p:sp>
-      <p:sp>
-        <p:nvSpPr>
-          <p:cNvPr id="11" name="TextBox 10"/>
-          <p:cNvSpPr txBox="1"/>
-          <p:nvPr/>
-        </p:nvSpPr>
-        <p:spPr>
-          <a:xfrm>
-            <a:off x="4364735" y="4637532"/>
+            <a:off x="4364735" y="4868384"/>
             <a:ext cx="1920240" cy="548640"/>
           </a:xfrm>
           <a:prstGeom prst="rect">
@@ -5362,7 +5009,7 @@
       </p:sp>
       <p:pic>
         <p:nvPicPr>
-          <p:cNvPr id="12" name="Picture 11" descr="3269d301dd5e8afa.png"/>
+          <p:cNvPr id="11" name="Picture 10" descr="3269d301dd5e8afa.png"/>
           <p:cNvPicPr>
             <a:picLocks noChangeAspect="1"/>
           </p:cNvPicPr>
@@ -5376,7 +5023,7 @@
         </p:blipFill>
         <p:spPr>
           <a:xfrm>
-            <a:off x="6284976" y="4480560"/>
+            <a:off x="6284976" y="4711412"/>
             <a:ext cx="1511808" cy="862584"/>
           </a:xfrm>
           <a:prstGeom prst="rect">
@@ -5507,44 +5154,9 @@
           </a:fontRef>
         </p:style>
       </p:cxnSp>
-      <p:sp>
-        <p:nvSpPr>
-          <p:cNvPr id="5" name="TextBox 4"/>
-          <p:cNvSpPr txBox="1"/>
-          <p:nvPr/>
-        </p:nvSpPr>
-        <p:spPr>
-          <a:xfrm>
-            <a:off x="777240" y="1261872"/>
-            <a:ext cx="10607040" cy="310896"/>
-          </a:xfrm>
-          <a:prstGeom prst="rect">
-            <a:avLst/>
-          </a:prstGeom>
-          <a:noFill/>
-        </p:spPr>
-        <p:txBody>
-          <a:bodyPr wrap="square" lIns="45720" rIns="45720" tIns="18288" bIns="18288" anchor="t">
-            <a:spAutoFit/>
-          </a:bodyPr>
-          <a:lstStyle/>
-          <a:p>
-            <a:pPr algn="l"/>
-            <a:r>
-              <a:rPr sz="1700" b="0" i="1">
-                <a:solidFill>
-                  <a:srgbClr val="6B6B6B"/>
-                </a:solidFill>
-                <a:latin typeface="Century Schoolbook"/>
-              </a:rPr>
-              <a:t>Boards up on three.</a:t>
-            </a:r>
-          </a:p>
-        </p:txBody>
-      </p:sp>
       <p:cxnSp>
         <p:nvCxnSpPr>
-          <p:cNvPr id="6" name="Connector 5"/>
+          <p:cNvPr id="5" name="Connector 4"/>
           <p:cNvCxnSpPr/>
           <p:nvPr/>
         </p:nvCxnSpPr>
@@ -5579,7 +5191,7 @@
       </p:cxnSp>
       <p:sp>
         <p:nvSpPr>
-          <p:cNvPr id="7" name="TextBox 6"/>
+          <p:cNvPr id="6" name="TextBox 5"/>
           <p:cNvSpPr txBox="1"/>
           <p:nvPr/>
         </p:nvSpPr>
@@ -5614,7 +5226,7 @@
       </p:sp>
       <p:sp>
         <p:nvSpPr>
-          <p:cNvPr id="8" name="TextBox 7"/>
+          <p:cNvPr id="7" name="TextBox 6"/>
           <p:cNvSpPr txBox="1"/>
           <p:nvPr/>
         </p:nvSpPr>
@@ -5649,7 +5261,7 @@
       </p:sp>
       <p:sp>
         <p:nvSpPr>
-          <p:cNvPr id="9" name="TextBox 8"/>
+          <p:cNvPr id="8" name="TextBox 7"/>
           <p:cNvSpPr txBox="1"/>
           <p:nvPr/>
         </p:nvSpPr>
@@ -5684,7 +5296,7 @@
       </p:sp>
       <p:pic>
         <p:nvPicPr>
-          <p:cNvPr id="10" name="Picture 9" descr="e8022fa09c25c018.png"/>
+          <p:cNvPr id="9" name="Picture 8" descr="e8022fa09c25c018.png"/>
           <p:cNvPicPr>
             <a:picLocks noChangeAspect="1"/>
           </p:cNvPicPr>
@@ -5708,7 +5320,7 @@
       </p:pic>
       <p:sp>
         <p:nvSpPr>
-          <p:cNvPr id="11" name="TextBox 10"/>
+          <p:cNvPr id="10" name="TextBox 9"/>
           <p:cNvSpPr txBox="1"/>
           <p:nvPr/>
         </p:nvSpPr>
@@ -5743,7 +5355,7 @@
       </p:sp>
       <p:sp>
         <p:nvSpPr>
-          <p:cNvPr id="12" name="TextBox 11"/>
+          <p:cNvPr id="11" name="TextBox 10"/>
           <p:cNvSpPr txBox="1"/>
           <p:nvPr/>
         </p:nvSpPr>
@@ -5778,7 +5390,7 @@
       </p:sp>
       <p:sp>
         <p:nvSpPr>
-          <p:cNvPr id="13" name="TextBox 12"/>
+          <p:cNvPr id="12" name="TextBox 11"/>
           <p:cNvSpPr txBox="1"/>
           <p:nvPr/>
         </p:nvSpPr>
@@ -5813,7 +5425,7 @@
       </p:sp>
       <p:sp>
         <p:nvSpPr>
-          <p:cNvPr id="14" name="TextBox 13"/>
+          <p:cNvPr id="13" name="TextBox 12"/>
           <p:cNvSpPr txBox="1"/>
           <p:nvPr/>
         </p:nvSpPr>
@@ -5969,44 +5581,9 @@
           </a:fontRef>
         </p:style>
       </p:cxnSp>
-      <p:sp>
-        <p:nvSpPr>
-          <p:cNvPr id="5" name="TextBox 4"/>
-          <p:cNvSpPr txBox="1"/>
-          <p:nvPr/>
-        </p:nvSpPr>
-        <p:spPr>
-          <a:xfrm>
-            <a:off x="777240" y="1261872"/>
-            <a:ext cx="10607040" cy="310896"/>
-          </a:xfrm>
-          <a:prstGeom prst="rect">
-            <a:avLst/>
-          </a:prstGeom>
-          <a:noFill/>
-        </p:spPr>
-        <p:txBody>
-          <a:bodyPr wrap="square" lIns="45720" rIns="45720" tIns="18288" bIns="18288" anchor="t">
-            <a:spAutoFit/>
-          </a:bodyPr>
-          <a:lstStyle/>
-          <a:p>
-            <a:pPr algn="l"/>
-            <a:r>
-              <a:rPr sz="1700" b="0" i="1">
-                <a:solidFill>
-                  <a:srgbClr val="6B6B6B"/>
-                </a:solidFill>
-                <a:latin typeface="Century Schoolbook"/>
-              </a:rPr>
-              <a:t>Answer.</a:t>
-            </a:r>
-          </a:p>
-        </p:txBody>
-      </p:sp>
       <p:cxnSp>
         <p:nvCxnSpPr>
-          <p:cNvPr id="6" name="Connector 5"/>
+          <p:cNvPr id="5" name="Connector 4"/>
           <p:cNvCxnSpPr/>
           <p:nvPr/>
         </p:nvCxnSpPr>
@@ -6041,7 +5618,7 @@
       </p:cxnSp>
       <p:sp>
         <p:nvSpPr>
-          <p:cNvPr id="7" name="TextBox 6"/>
+          <p:cNvPr id="6" name="TextBox 5"/>
           <p:cNvSpPr txBox="1"/>
           <p:nvPr/>
         </p:nvSpPr>
@@ -6076,7 +5653,7 @@
       </p:sp>
       <p:sp>
         <p:nvSpPr>
-          <p:cNvPr id="8" name="TextBox 7"/>
+          <p:cNvPr id="7" name="TextBox 6"/>
           <p:cNvSpPr txBox="1"/>
           <p:nvPr/>
         </p:nvSpPr>
@@ -6111,7 +5688,7 @@
       </p:sp>
       <p:sp>
         <p:nvSpPr>
-          <p:cNvPr id="9" name="TextBox 8"/>
+          <p:cNvPr id="8" name="TextBox 7"/>
           <p:cNvSpPr txBox="1"/>
           <p:nvPr/>
         </p:nvSpPr>
@@ -6146,7 +5723,7 @@
       </p:sp>
       <p:pic>
         <p:nvPicPr>
-          <p:cNvPr id="10" name="Picture 9" descr="024e90b41a6caf45.png"/>
+          <p:cNvPr id="9" name="Picture 8" descr="024e90b41a6caf45.png"/>
           <p:cNvPicPr>
             <a:picLocks noChangeAspect="1"/>
           </p:cNvPicPr>
@@ -6170,7 +5747,7 @@
       </p:pic>
       <p:sp>
         <p:nvSpPr>
-          <p:cNvPr id="11" name="TextBox 10"/>
+          <p:cNvPr id="10" name="TextBox 9"/>
           <p:cNvSpPr txBox="1"/>
           <p:nvPr/>
         </p:nvSpPr>
@@ -6205,7 +5782,7 @@
       </p:sp>
       <p:sp>
         <p:nvSpPr>
-          <p:cNvPr id="12" name="TextBox 11"/>
+          <p:cNvPr id="11" name="TextBox 10"/>
           <p:cNvSpPr txBox="1"/>
           <p:nvPr/>
         </p:nvSpPr>
@@ -6240,7 +5817,7 @@
       </p:sp>
       <p:sp>
         <p:nvSpPr>
-          <p:cNvPr id="13" name="TextBox 12"/>
+          <p:cNvPr id="12" name="TextBox 11"/>
           <p:cNvSpPr txBox="1"/>
           <p:nvPr/>
         </p:nvSpPr>
@@ -6275,93 +5852,13 @@
       </p:sp>
       <p:sp>
         <p:nvSpPr>
-          <p:cNvPr id="14" name="TextBox 13"/>
-          <p:cNvSpPr txBox="1"/>
-          <p:nvPr/>
-        </p:nvSpPr>
-        <p:spPr>
-          <a:xfrm>
-            <a:off x="1828800" y="4229431"/>
-            <a:ext cx="8503920" cy="548640"/>
-          </a:xfrm>
-          <a:prstGeom prst="rect">
-            <a:avLst/>
-          </a:prstGeom>
-          <a:noFill/>
-        </p:spPr>
-        <p:txBody>
-          <a:bodyPr wrap="square" lIns="45720" rIns="45720" tIns="18288" bIns="18288" anchor="t">
-            <a:spAutoFit/>
-          </a:bodyPr>
-          <a:lstStyle/>
-          <a:p>
-            <a:pPr algn="ctr"/>
-            <a:r>
-              <a:rPr sz="2400" b="0" i="0">
-                <a:solidFill>
-                  <a:srgbClr val="6B6B6B"/>
-                </a:solidFill>
-                <a:latin typeface="Century Schoolbook"/>
-              </a:rPr>
-              <a:t>(2/3)</a:t>
-            </a:r>
-            <a:r>
-              <a:rPr sz="2400" b="0" i="0" baseline="30000">
-                <a:solidFill>
-                  <a:srgbClr val="6B6B6B"/>
-                </a:solidFill>
-                <a:latin typeface="Century Schoolbook"/>
-              </a:rPr>
-              <a:t>4</a:t>
-            </a:r>
-            <a:r>
-              <a:rPr sz="2400" b="0" i="0">
-                <a:solidFill>
-                  <a:srgbClr val="6B6B6B"/>
-                </a:solidFill>
-                <a:latin typeface="Century Schoolbook"/>
-              </a:rPr>
-              <a:t> = 2</a:t>
-            </a:r>
-            <a:r>
-              <a:rPr sz="2400" b="0" i="0" baseline="30000">
-                <a:solidFill>
-                  <a:srgbClr val="6B6B6B"/>
-                </a:solidFill>
-                <a:latin typeface="Century Schoolbook"/>
-              </a:rPr>
-              <a:t>4</a:t>
-            </a:r>
-            <a:r>
-              <a:rPr sz="2400" b="0" i="0">
-                <a:solidFill>
-                  <a:srgbClr val="6B6B6B"/>
-                </a:solidFill>
-                <a:latin typeface="Century Schoolbook"/>
-              </a:rPr>
-              <a:t> over 3</a:t>
-            </a:r>
-            <a:r>
-              <a:rPr sz="2400" b="0" i="0" baseline="30000">
-                <a:solidFill>
-                  <a:srgbClr val="6B6B6B"/>
-                </a:solidFill>
-                <a:latin typeface="Century Schoolbook"/>
-              </a:rPr>
-              <a:t>4</a:t>
-            </a:r>
-          </a:p>
-        </p:txBody>
-      </p:sp>
-      <p:sp>
-        <p:nvSpPr>
-          <p:cNvPr id="15" name="TextBox 14"/>
-          <p:cNvSpPr txBox="1"/>
-          <p:nvPr/>
-        </p:nvSpPr>
-        <p:spPr>
-          <a:xfrm>
-            <a:off x="4864607" y="5120971"/>
+          <p:cNvPr id="13" name="TextBox 12"/>
+          <p:cNvSpPr txBox="1"/>
+          <p:nvPr/>
+        </p:nvSpPr>
+        <p:spPr>
+          <a:xfrm>
+            <a:off x="4864607" y="4823459"/>
             <a:ext cx="1920240" cy="548640"/>
           </a:xfrm>
           <a:prstGeom prst="rect">
@@ -6390,7 +5887,7 @@
       </p:sp>
       <p:pic>
         <p:nvPicPr>
-          <p:cNvPr id="16" name="Picture 15" descr="7dd35ac51a0ee44c.png"/>
+          <p:cNvPr id="14" name="Picture 13" descr="7dd35ac51a0ee44c.png"/>
           <p:cNvPicPr>
             <a:picLocks noChangeAspect="1"/>
           </p:cNvPicPr>
@@ -6404,7 +5901,7 @@
         </p:blipFill>
         <p:spPr>
           <a:xfrm>
-            <a:off x="6784848" y="4960951"/>
+            <a:off x="6784848" y="4663440"/>
             <a:ext cx="512064" cy="868680"/>
           </a:xfrm>
           <a:prstGeom prst="rect">
@@ -6535,44 +6032,9 @@
           </a:fontRef>
         </p:style>
       </p:cxnSp>
-      <p:sp>
-        <p:nvSpPr>
-          <p:cNvPr id="5" name="TextBox 4"/>
-          <p:cNvSpPr txBox="1"/>
-          <p:nvPr/>
-        </p:nvSpPr>
-        <p:spPr>
-          <a:xfrm>
-            <a:off x="777240" y="1261872"/>
-            <a:ext cx="10607040" cy="310896"/>
-          </a:xfrm>
-          <a:prstGeom prst="rect">
-            <a:avLst/>
-          </a:prstGeom>
-          <a:noFill/>
-        </p:spPr>
-        <p:txBody>
-          <a:bodyPr wrap="square" lIns="45720" rIns="45720" tIns="18288" bIns="18288" anchor="t">
-            <a:spAutoFit/>
-          </a:bodyPr>
-          <a:lstStyle/>
-          <a:p>
-            <a:pPr algn="l"/>
-            <a:r>
-              <a:rPr sz="1700" b="0" i="1">
-                <a:solidFill>
-                  <a:srgbClr val="6B6B6B"/>
-                </a:solidFill>
-                <a:latin typeface="Century Schoolbook"/>
-              </a:rPr>
-              <a:t>Boards up on three.</a:t>
-            </a:r>
-          </a:p>
-        </p:txBody>
-      </p:sp>
       <p:cxnSp>
         <p:nvCxnSpPr>
-          <p:cNvPr id="6" name="Connector 5"/>
+          <p:cNvPr id="5" name="Connector 4"/>
           <p:cNvCxnSpPr/>
           <p:nvPr/>
         </p:nvCxnSpPr>
@@ -6607,7 +6069,7 @@
       </p:cxnSp>
       <p:sp>
         <p:nvSpPr>
-          <p:cNvPr id="7" name="TextBox 6"/>
+          <p:cNvPr id="6" name="TextBox 5"/>
           <p:cNvSpPr txBox="1"/>
           <p:nvPr/>
         </p:nvSpPr>
@@ -6642,7 +6104,7 @@
       </p:sp>
       <p:sp>
         <p:nvSpPr>
-          <p:cNvPr id="8" name="TextBox 7"/>
+          <p:cNvPr id="7" name="TextBox 6"/>
           <p:cNvSpPr txBox="1"/>
           <p:nvPr/>
         </p:nvSpPr>
@@ -6677,7 +6139,7 @@
       </p:sp>
       <p:pic>
         <p:nvPicPr>
-          <p:cNvPr id="9" name="Picture 8" descr="23a87bc643d7e5a2.png"/>
+          <p:cNvPr id="8" name="Picture 7" descr="23a87bc643d7e5a2.png"/>
           <p:cNvPicPr>
             <a:picLocks noChangeAspect="1"/>
           </p:cNvPicPr>
@@ -6701,7 +6163,7 @@
       </p:pic>
       <p:sp>
         <p:nvSpPr>
-          <p:cNvPr id="10" name="TextBox 9"/>
+          <p:cNvPr id="9" name="TextBox 8"/>
           <p:cNvSpPr txBox="1"/>
           <p:nvPr/>
         </p:nvSpPr>
@@ -6730,41 +6192,6 @@
                 <a:latin typeface="Century Schoolbook"/>
               </a:rPr>
               <a:t>Answer it.</a:t>
-            </a:r>
-          </a:p>
-        </p:txBody>
-      </p:sp>
-      <p:sp>
-        <p:nvSpPr>
-          <p:cNvPr id="11" name="TextBox 10"/>
-          <p:cNvSpPr txBox="1"/>
-          <p:nvPr/>
-        </p:nvSpPr>
-        <p:spPr>
-          <a:xfrm>
-            <a:off x="777240" y="4828032"/>
-            <a:ext cx="10607040" cy="365760"/>
-          </a:xfrm>
-          <a:prstGeom prst="rect">
-            <a:avLst/>
-          </a:prstGeom>
-          <a:noFill/>
-        </p:spPr>
-        <p:txBody>
-          <a:bodyPr wrap="square" lIns="45720" rIns="45720" tIns="18288" bIns="18288" anchor="t">
-            <a:spAutoFit/>
-          </a:bodyPr>
-          <a:lstStyle/>
-          <a:p>
-            <a:pPr algn="ctr"/>
-            <a:r>
-              <a:rPr sz="1900" b="0" i="1">
-                <a:solidFill>
-                  <a:srgbClr val="6B6B6B"/>
-                </a:solidFill>
-                <a:latin typeface="Century Schoolbook"/>
-              </a:rPr>
-              <a:t>Rewrite with a positive exponent.</a:t>
             </a:r>
           </a:p>
         </p:txBody>
@@ -6892,44 +6319,9 @@
           </a:fontRef>
         </p:style>
       </p:cxnSp>
-      <p:sp>
-        <p:nvSpPr>
-          <p:cNvPr id="5" name="TextBox 4"/>
-          <p:cNvSpPr txBox="1"/>
-          <p:nvPr/>
-        </p:nvSpPr>
-        <p:spPr>
-          <a:xfrm>
-            <a:off x="777240" y="1261872"/>
-            <a:ext cx="10607040" cy="310896"/>
-          </a:xfrm>
-          <a:prstGeom prst="rect">
-            <a:avLst/>
-          </a:prstGeom>
-          <a:noFill/>
-        </p:spPr>
-        <p:txBody>
-          <a:bodyPr wrap="square" lIns="45720" rIns="45720" tIns="18288" bIns="18288" anchor="t">
-            <a:spAutoFit/>
-          </a:bodyPr>
-          <a:lstStyle/>
-          <a:p>
-            <a:pPr algn="l"/>
-            <a:r>
-              <a:rPr sz="1700" b="0" i="1">
-                <a:solidFill>
-                  <a:srgbClr val="6B6B6B"/>
-                </a:solidFill>
-                <a:latin typeface="Century Schoolbook"/>
-              </a:rPr>
-              <a:t>Answer.</a:t>
-            </a:r>
-          </a:p>
-        </p:txBody>
-      </p:sp>
       <p:cxnSp>
         <p:nvCxnSpPr>
-          <p:cNvPr id="6" name="Connector 5"/>
+          <p:cNvPr id="5" name="Connector 4"/>
           <p:cNvCxnSpPr/>
           <p:nvPr/>
         </p:nvCxnSpPr>
@@ -6964,7 +6356,7 @@
       </p:cxnSp>
       <p:sp>
         <p:nvSpPr>
-          <p:cNvPr id="7" name="TextBox 6"/>
+          <p:cNvPr id="6" name="TextBox 5"/>
           <p:cNvSpPr txBox="1"/>
           <p:nvPr/>
         </p:nvSpPr>
@@ -6999,7 +6391,7 @@
       </p:sp>
       <p:sp>
         <p:nvSpPr>
-          <p:cNvPr id="8" name="TextBox 7"/>
+          <p:cNvPr id="7" name="TextBox 6"/>
           <p:cNvSpPr txBox="1"/>
           <p:nvPr/>
         </p:nvSpPr>
@@ -7034,7 +6426,7 @@
       </p:sp>
       <p:pic>
         <p:nvPicPr>
-          <p:cNvPr id="9" name="Picture 8" descr="7b4aab4c0a6cc8a0.png"/>
+          <p:cNvPr id="8" name="Picture 7" descr="7b4aab4c0a6cc8a0.png"/>
           <p:cNvPicPr>
             <a:picLocks noChangeAspect="1"/>
           </p:cNvPicPr>
@@ -7058,42 +6450,7 @@
       </p:pic>
       <p:sp>
         <p:nvSpPr>
-          <p:cNvPr id="10" name="TextBox 9"/>
-          <p:cNvSpPr txBox="1"/>
-          <p:nvPr/>
-        </p:nvSpPr>
-        <p:spPr>
-          <a:xfrm>
-            <a:off x="1828800" y="3246120"/>
-            <a:ext cx="8503920" cy="548640"/>
-          </a:xfrm>
-          <a:prstGeom prst="rect">
-            <a:avLst/>
-          </a:prstGeom>
-          <a:noFill/>
-        </p:spPr>
-        <p:txBody>
-          <a:bodyPr wrap="square" lIns="45720" rIns="45720" tIns="18288" bIns="18288" anchor="t">
-            <a:spAutoFit/>
-          </a:bodyPr>
-          <a:lstStyle/>
-          <a:p>
-            <a:pPr algn="ctr"/>
-            <a:r>
-              <a:rPr sz="2400" b="0" i="0">
-                <a:solidFill>
-                  <a:srgbClr val="6B6B6B"/>
-                </a:solidFill>
-                <a:latin typeface="Century Schoolbook"/>
-              </a:rPr>
-              <a:t>flip the numbers; the sign stays in the fraction</a:t>
-            </a:r>
-          </a:p>
-        </p:txBody>
-      </p:sp>
-      <p:sp>
-        <p:nvSpPr>
-          <p:cNvPr id="11" name="TextBox 10"/>
+          <p:cNvPr id="9" name="TextBox 8"/>
           <p:cNvSpPr txBox="1"/>
           <p:nvPr/>
         </p:nvSpPr>
@@ -7128,7 +6485,7 @@
       </p:sp>
       <p:pic>
         <p:nvPicPr>
-          <p:cNvPr id="12" name="Picture 11" descr="837676bd53bd7ebc.png"/>
+          <p:cNvPr id="10" name="Picture 9" descr="837676bd53bd7ebc.png"/>
           <p:cNvPicPr>
             <a:picLocks noChangeAspect="1"/>
           </p:cNvPicPr>
@@ -7273,44 +6630,9 @@
           </a:fontRef>
         </p:style>
       </p:cxnSp>
-      <p:sp>
-        <p:nvSpPr>
-          <p:cNvPr id="5" name="TextBox 4"/>
-          <p:cNvSpPr txBox="1"/>
-          <p:nvPr/>
-        </p:nvSpPr>
-        <p:spPr>
-          <a:xfrm>
-            <a:off x="777240" y="1261872"/>
-            <a:ext cx="10607040" cy="310896"/>
-          </a:xfrm>
-          <a:prstGeom prst="rect">
-            <a:avLst/>
-          </a:prstGeom>
-          <a:noFill/>
-        </p:spPr>
-        <p:txBody>
-          <a:bodyPr wrap="square" lIns="45720" rIns="45720" tIns="18288" bIns="18288" anchor="t">
-            <a:spAutoFit/>
-          </a:bodyPr>
-          <a:lstStyle/>
-          <a:p>
-            <a:pPr algn="l"/>
-            <a:r>
-              <a:rPr sz="1700" b="0" i="1">
-                <a:solidFill>
-                  <a:srgbClr val="6B6B6B"/>
-                </a:solidFill>
-                <a:latin typeface="Century Schoolbook"/>
-              </a:rPr>
-              <a:t>Boards up on three.</a:t>
-            </a:r>
-          </a:p>
-        </p:txBody>
-      </p:sp>
       <p:cxnSp>
         <p:nvCxnSpPr>
-          <p:cNvPr id="6" name="Connector 5"/>
+          <p:cNvPr id="5" name="Connector 4"/>
           <p:cNvCxnSpPr/>
           <p:nvPr/>
         </p:nvCxnSpPr>
@@ -7345,7 +6667,7 @@
       </p:cxnSp>
       <p:sp>
         <p:nvSpPr>
-          <p:cNvPr id="7" name="TextBox 6"/>
+          <p:cNvPr id="6" name="TextBox 5"/>
           <p:cNvSpPr txBox="1"/>
           <p:nvPr/>
         </p:nvSpPr>
@@ -7380,7 +6702,7 @@
       </p:sp>
       <p:sp>
         <p:nvSpPr>
-          <p:cNvPr id="8" name="TextBox 7"/>
+          <p:cNvPr id="7" name="TextBox 6"/>
           <p:cNvSpPr txBox="1"/>
           <p:nvPr/>
         </p:nvSpPr>
@@ -7415,7 +6737,7 @@
       </p:sp>
       <p:pic>
         <p:nvPicPr>
-          <p:cNvPr id="9" name="Picture 8" descr="c08fd56f1b4e345e.png"/>
+          <p:cNvPr id="8" name="Picture 7" descr="c08fd56f1b4e345e.png"/>
           <p:cNvPicPr>
             <a:picLocks noChangeAspect="1"/>
           </p:cNvPicPr>
@@ -7439,7 +6761,7 @@
       </p:pic>
       <p:sp>
         <p:nvSpPr>
-          <p:cNvPr id="10" name="TextBox 9"/>
+          <p:cNvPr id="9" name="TextBox 8"/>
           <p:cNvSpPr txBox="1"/>
           <p:nvPr/>
         </p:nvSpPr>
@@ -7468,41 +6790,6 @@
                 <a:latin typeface="Century Schoolbook"/>
               </a:rPr>
               <a:t>Answer it.</a:t>
-            </a:r>
-          </a:p>
-        </p:txBody>
-      </p:sp>
-      <p:sp>
-        <p:nvSpPr>
-          <p:cNvPr id="11" name="TextBox 10"/>
-          <p:cNvSpPr txBox="1"/>
-          <p:nvPr/>
-        </p:nvSpPr>
-        <p:spPr>
-          <a:xfrm>
-            <a:off x="777240" y="4828032"/>
-            <a:ext cx="10607040" cy="365760"/>
-          </a:xfrm>
-          <a:prstGeom prst="rect">
-            <a:avLst/>
-          </a:prstGeom>
-          <a:noFill/>
-        </p:spPr>
-        <p:txBody>
-          <a:bodyPr wrap="square" lIns="45720" rIns="45720" tIns="18288" bIns="18288" anchor="t">
-            <a:spAutoFit/>
-          </a:bodyPr>
-          <a:lstStyle/>
-          <a:p>
-            <a:pPr algn="ctr"/>
-            <a:r>
-              <a:rPr sz="1900" b="0" i="1">
-                <a:solidFill>
-                  <a:srgbClr val="6B6B6B"/>
-                </a:solidFill>
-                <a:latin typeface="Century Schoolbook"/>
-              </a:rPr>
-              <a:t>Find the value.</a:t>
             </a:r>
           </a:p>
         </p:txBody>
@@ -7630,44 +6917,9 @@
           </a:fontRef>
         </p:style>
       </p:cxnSp>
-      <p:sp>
-        <p:nvSpPr>
-          <p:cNvPr id="5" name="TextBox 4"/>
-          <p:cNvSpPr txBox="1"/>
-          <p:nvPr/>
-        </p:nvSpPr>
-        <p:spPr>
-          <a:xfrm>
-            <a:off x="777240" y="1261872"/>
-            <a:ext cx="10607040" cy="310896"/>
-          </a:xfrm>
-          <a:prstGeom prst="rect">
-            <a:avLst/>
-          </a:prstGeom>
-          <a:noFill/>
-        </p:spPr>
-        <p:txBody>
-          <a:bodyPr wrap="square" lIns="45720" rIns="45720" tIns="18288" bIns="18288" anchor="t">
-            <a:spAutoFit/>
-          </a:bodyPr>
-          <a:lstStyle/>
-          <a:p>
-            <a:pPr algn="l"/>
-            <a:r>
-              <a:rPr sz="1700" b="0" i="1">
-                <a:solidFill>
-                  <a:srgbClr val="6B6B6B"/>
-                </a:solidFill>
-                <a:latin typeface="Century Schoolbook"/>
-              </a:rPr>
-              <a:t>On your own. Four minutes. No notes.</a:t>
-            </a:r>
-          </a:p>
-        </p:txBody>
-      </p:sp>
       <p:cxnSp>
         <p:nvCxnSpPr>
-          <p:cNvPr id="6" name="Connector 5"/>
+          <p:cNvPr id="5" name="Connector 4"/>
           <p:cNvCxnSpPr/>
           <p:nvPr/>
         </p:nvCxnSpPr>
@@ -7702,7 +6954,7 @@
       </p:cxnSp>
       <p:sp>
         <p:nvSpPr>
-          <p:cNvPr id="7" name="TextBox 6"/>
+          <p:cNvPr id="6" name="TextBox 5"/>
           <p:cNvSpPr txBox="1"/>
           <p:nvPr/>
         </p:nvSpPr>
@@ -7737,7 +6989,7 @@
       </p:sp>
       <p:sp>
         <p:nvSpPr>
-          <p:cNvPr id="8" name="TextBox 7"/>
+          <p:cNvPr id="7" name="TextBox 6"/>
           <p:cNvSpPr txBox="1"/>
           <p:nvPr/>
         </p:nvSpPr>
@@ -7772,13 +7024,13 @@
       </p:sp>
       <p:sp>
         <p:nvSpPr>
-          <p:cNvPr id="9" name="TextBox 8"/>
-          <p:cNvSpPr txBox="1"/>
-          <p:nvPr/>
-        </p:nvSpPr>
-        <p:spPr>
-          <a:xfrm>
-            <a:off x="1874519" y="1760220"/>
+          <p:cNvPr id="8" name="TextBox 7"/>
+          <p:cNvSpPr txBox="1"/>
+          <p:nvPr/>
+        </p:nvSpPr>
+        <p:spPr>
+          <a:xfrm>
+            <a:off x="1874519" y="1440180"/>
             <a:ext cx="3058734" cy="457200"/>
           </a:xfrm>
           <a:prstGeom prst="rect">
@@ -7807,7 +7059,7 @@
       </p:sp>
       <p:pic>
         <p:nvPicPr>
-          <p:cNvPr id="10" name="Picture 9" descr="1538ef9a323bca44.png"/>
+          <p:cNvPr id="9" name="Picture 8" descr="1538ef9a323bca44.png"/>
           <p:cNvPicPr>
             <a:picLocks noChangeAspect="1"/>
           </p:cNvPicPr>
@@ -7821,7 +7073,7 @@
         </p:blipFill>
         <p:spPr>
           <a:xfrm>
-            <a:off x="4796094" y="1851660"/>
+            <a:off x="4796094" y="1531620"/>
             <a:ext cx="417576" cy="274320"/>
           </a:xfrm>
           <a:prstGeom prst="rect">
@@ -7831,13 +7083,13 @@
       </p:pic>
       <p:sp>
         <p:nvSpPr>
-          <p:cNvPr id="11" name="TextBox 10"/>
-          <p:cNvSpPr txBox="1"/>
-          <p:nvPr/>
-        </p:nvSpPr>
-        <p:spPr>
-          <a:xfrm>
-            <a:off x="1874519" y="2468880"/>
+          <p:cNvPr id="10" name="TextBox 9"/>
+          <p:cNvSpPr txBox="1"/>
+          <p:nvPr/>
+        </p:nvSpPr>
+        <p:spPr>
+          <a:xfrm>
+            <a:off x="1874519" y="2148840"/>
             <a:ext cx="5677198" cy="457200"/>
           </a:xfrm>
           <a:prstGeom prst="rect">
@@ -7866,7 +7118,7 @@
       </p:sp>
       <p:pic>
         <p:nvPicPr>
-          <p:cNvPr id="12" name="Picture 11" descr="82be0161615a5d7f.png"/>
+          <p:cNvPr id="11" name="Picture 10" descr="82be0161615a5d7f.png"/>
           <p:cNvPicPr>
             <a:picLocks noChangeAspect="1"/>
           </p:cNvPicPr>
@@ -7880,7 +7132,7 @@
         </p:blipFill>
         <p:spPr>
           <a:xfrm>
-            <a:off x="7414558" y="2395728"/>
+            <a:off x="7414558" y="2075688"/>
             <a:ext cx="463296" cy="603504"/>
           </a:xfrm>
           <a:prstGeom prst="rect">
@@ -7890,13 +7142,13 @@
       </p:pic>
       <p:sp>
         <p:nvSpPr>
-          <p:cNvPr id="13" name="TextBox 12"/>
-          <p:cNvSpPr txBox="1"/>
-          <p:nvPr/>
-        </p:nvSpPr>
-        <p:spPr>
-          <a:xfrm>
-            <a:off x="1874519" y="3177540"/>
+          <p:cNvPr id="12" name="TextBox 11"/>
+          <p:cNvSpPr txBox="1"/>
+          <p:nvPr/>
+        </p:nvSpPr>
+        <p:spPr>
+          <a:xfrm>
+            <a:off x="1874519" y="2857500"/>
             <a:ext cx="3065570" cy="457200"/>
           </a:xfrm>
           <a:prstGeom prst="rect">
@@ -7925,7 +7177,7 @@
       </p:sp>
       <p:pic>
         <p:nvPicPr>
-          <p:cNvPr id="14" name="Picture 13" descr="5fa67493f2d0b1ad.png"/>
+          <p:cNvPr id="13" name="Picture 12" descr="5fa67493f2d0b1ad.png"/>
           <p:cNvPicPr>
             <a:picLocks noChangeAspect="1"/>
           </p:cNvPicPr>
@@ -7939,7 +7191,7 @@
         </p:blipFill>
         <p:spPr>
           <a:xfrm>
-            <a:off x="4802930" y="3268980"/>
+            <a:off x="4802930" y="2948940"/>
             <a:ext cx="265176" cy="274320"/>
           </a:xfrm>
           <a:prstGeom prst="rect">
@@ -7949,13 +7201,13 @@
       </p:pic>
       <p:sp>
         <p:nvSpPr>
-          <p:cNvPr id="15" name="TextBox 14"/>
-          <p:cNvSpPr txBox="1"/>
-          <p:nvPr/>
-        </p:nvSpPr>
-        <p:spPr>
-          <a:xfrm>
-            <a:off x="5068106" y="3177540"/>
+          <p:cNvPr id="14" name="TextBox 13"/>
+          <p:cNvSpPr txBox="1"/>
+          <p:nvPr/>
+        </p:nvSpPr>
+        <p:spPr>
+          <a:xfrm>
+            <a:off x="5068106" y="2857500"/>
             <a:ext cx="674751" cy="457200"/>
           </a:xfrm>
           <a:prstGeom prst="rect">
@@ -7984,7 +7236,7 @@
       </p:sp>
       <p:pic>
         <p:nvPicPr>
-          <p:cNvPr id="16" name="Picture 15" descr="cd79bb74d01bc946.png"/>
+          <p:cNvPr id="15" name="Picture 14" descr="cd79bb74d01bc946.png"/>
           <p:cNvPicPr>
             <a:picLocks noChangeAspect="1"/>
           </p:cNvPicPr>
@@ -7998,7 +7250,7 @@
         </p:blipFill>
         <p:spPr>
           <a:xfrm>
-            <a:off x="5605697" y="3264408"/>
+            <a:off x="5605697" y="2944368"/>
             <a:ext cx="265176" cy="283464"/>
           </a:xfrm>
           <a:prstGeom prst="rect">
@@ -8008,13 +7260,13 @@
       </p:pic>
       <p:sp>
         <p:nvSpPr>
-          <p:cNvPr id="17" name="TextBox 16"/>
-          <p:cNvSpPr txBox="1"/>
-          <p:nvPr/>
-        </p:nvSpPr>
-        <p:spPr>
-          <a:xfrm>
-            <a:off x="5870873" y="3177540"/>
+          <p:cNvPr id="16" name="TextBox 15"/>
+          <p:cNvSpPr txBox="1"/>
+          <p:nvPr/>
+        </p:nvSpPr>
+        <p:spPr>
+          <a:xfrm>
+            <a:off x="5870873" y="2857500"/>
             <a:ext cx="347771" cy="457200"/>
           </a:xfrm>
           <a:prstGeom prst="rect">
@@ -8043,13 +7295,13 @@
       </p:sp>
       <p:sp>
         <p:nvSpPr>
-          <p:cNvPr id="18" name="TextBox 17"/>
-          <p:cNvSpPr txBox="1"/>
-          <p:nvPr/>
-        </p:nvSpPr>
-        <p:spPr>
-          <a:xfrm>
-            <a:off x="1874519" y="3863340"/>
+          <p:cNvPr id="17" name="TextBox 16"/>
+          <p:cNvSpPr txBox="1"/>
+          <p:nvPr/>
+        </p:nvSpPr>
+        <p:spPr>
+          <a:xfrm>
+            <a:off x="1874519" y="3543300"/>
             <a:ext cx="4084107" cy="457200"/>
           </a:xfrm>
           <a:prstGeom prst="rect">
@@ -8078,7 +7330,7 @@
       </p:sp>
       <p:pic>
         <p:nvPicPr>
-          <p:cNvPr id="19" name="Picture 18" descr="e5446a4e89f9a3af.png"/>
+          <p:cNvPr id="18" name="Picture 17" descr="e5446a4e89f9a3af.png"/>
           <p:cNvPicPr>
             <a:picLocks noChangeAspect="1"/>
           </p:cNvPicPr>
@@ -8092,7 +7344,7 @@
         </p:blipFill>
         <p:spPr>
           <a:xfrm>
-            <a:off x="5821467" y="3813048"/>
+            <a:off x="5821467" y="3493008"/>
             <a:ext cx="377952" cy="557784"/>
           </a:xfrm>
           <a:prstGeom prst="rect">
@@ -8223,44 +7475,9 @@
           </a:fontRef>
         </p:style>
       </p:cxnSp>
-      <p:sp>
-        <p:nvSpPr>
-          <p:cNvPr id="5" name="TextBox 4"/>
-          <p:cNvSpPr txBox="1"/>
-          <p:nvPr/>
-        </p:nvSpPr>
-        <p:spPr>
-          <a:xfrm>
-            <a:off x="777240" y="1261872"/>
-            <a:ext cx="10607040" cy="310896"/>
-          </a:xfrm>
-          <a:prstGeom prst="rect">
-            <a:avLst/>
-          </a:prstGeom>
-          <a:noFill/>
-        </p:spPr>
-        <p:txBody>
-          <a:bodyPr wrap="square" lIns="45720" rIns="45720" tIns="18288" bIns="18288" anchor="t">
-            <a:spAutoFit/>
-          </a:bodyPr>
-          <a:lstStyle/>
-          <a:p>
-            <a:pPr algn="l"/>
-            <a:r>
-              <a:rPr sz="1700" b="0" i="1">
-                <a:solidFill>
-                  <a:srgbClr val="6B6B6B"/>
-                </a:solidFill>
-                <a:latin typeface="Century Schoolbook"/>
-              </a:rPr>
-              <a:t>Answer.</a:t>
-            </a:r>
-          </a:p>
-        </p:txBody>
-      </p:sp>
       <p:cxnSp>
         <p:nvCxnSpPr>
-          <p:cNvPr id="6" name="Connector 5"/>
+          <p:cNvPr id="5" name="Connector 4"/>
           <p:cNvCxnSpPr/>
           <p:nvPr/>
         </p:nvCxnSpPr>
@@ -8295,7 +7512,7 @@
       </p:cxnSp>
       <p:sp>
         <p:nvSpPr>
-          <p:cNvPr id="7" name="TextBox 6"/>
+          <p:cNvPr id="6" name="TextBox 5"/>
           <p:cNvSpPr txBox="1"/>
           <p:nvPr/>
         </p:nvSpPr>
@@ -8330,7 +7547,7 @@
       </p:sp>
       <p:sp>
         <p:nvSpPr>
-          <p:cNvPr id="8" name="TextBox 7"/>
+          <p:cNvPr id="7" name="TextBox 6"/>
           <p:cNvSpPr txBox="1"/>
           <p:nvPr/>
         </p:nvSpPr>
@@ -8365,7 +7582,7 @@
       </p:sp>
       <p:pic>
         <p:nvPicPr>
-          <p:cNvPr id="9" name="Picture 8" descr="bc194338a8886ecd.png"/>
+          <p:cNvPr id="8" name="Picture 7" descr="bc194338a8886ecd.png"/>
           <p:cNvPicPr>
             <a:picLocks noChangeAspect="1"/>
           </p:cNvPicPr>
@@ -8389,60 +7606,7 @@
       </p:pic>
       <p:sp>
         <p:nvSpPr>
-          <p:cNvPr id="10" name="TextBox 9"/>
-          <p:cNvSpPr txBox="1"/>
-          <p:nvPr/>
-        </p:nvSpPr>
-        <p:spPr>
-          <a:xfrm>
-            <a:off x="1828800" y="3246120"/>
-            <a:ext cx="8503920" cy="548640"/>
-          </a:xfrm>
-          <a:prstGeom prst="rect">
-            <a:avLst/>
-          </a:prstGeom>
-          <a:noFill/>
-        </p:spPr>
-        <p:txBody>
-          <a:bodyPr wrap="square" lIns="45720" rIns="45720" tIns="18288" bIns="18288" anchor="t">
-            <a:spAutoFit/>
-          </a:bodyPr>
-          <a:lstStyle/>
-          <a:p>
-            <a:pPr algn="ctr"/>
-            <a:r>
-              <a:rPr sz="2400" b="0" i="0">
-                <a:solidFill>
-                  <a:srgbClr val="6B6B6B"/>
-                </a:solidFill>
-                <a:latin typeface="Century Schoolbook"/>
-              </a:rPr>
-              <a:t>(−9/8)</a:t>
-            </a:r>
-            <a:r>
-              <a:rPr sz="2400" b="0" i="0" baseline="30000">
-                <a:solidFill>
-                  <a:srgbClr val="6B6B6B"/>
-                </a:solidFill>
-                <a:latin typeface="Century Schoolbook"/>
-              </a:rPr>
-              <a:t>2</a:t>
-            </a:r>
-            <a:r>
-              <a:rPr sz="2400" b="0" i="0">
-                <a:solidFill>
-                  <a:srgbClr val="6B6B6B"/>
-                </a:solidFill>
-                <a:latin typeface="Century Schoolbook"/>
-              </a:rPr>
-              <a:t> = 81/64</a:t>
-            </a:r>
-          </a:p>
-        </p:txBody>
-      </p:sp>
-      <p:sp>
-        <p:nvSpPr>
-          <p:cNvPr id="11" name="TextBox 10"/>
+          <p:cNvPr id="9" name="TextBox 8"/>
           <p:cNvSpPr txBox="1"/>
           <p:nvPr/>
         </p:nvSpPr>
@@ -8477,7 +7641,7 @@
       </p:sp>
       <p:pic>
         <p:nvPicPr>
-          <p:cNvPr id="12" name="Picture 11" descr="3148abf2051aaac1.png"/>
+          <p:cNvPr id="10" name="Picture 9" descr="3148abf2051aaac1.png"/>
           <p:cNvPicPr>
             <a:picLocks noChangeAspect="1"/>
           </p:cNvPicPr>
@@ -8622,44 +7786,9 @@
           </a:fontRef>
         </p:style>
       </p:cxnSp>
-      <p:sp>
-        <p:nvSpPr>
-          <p:cNvPr id="5" name="TextBox 4"/>
-          <p:cNvSpPr txBox="1"/>
-          <p:nvPr/>
-        </p:nvSpPr>
-        <p:spPr>
-          <a:xfrm>
-            <a:off x="777240" y="1261872"/>
-            <a:ext cx="10607040" cy="310896"/>
-          </a:xfrm>
-          <a:prstGeom prst="rect">
-            <a:avLst/>
-          </a:prstGeom>
-          <a:noFill/>
-        </p:spPr>
-        <p:txBody>
-          <a:bodyPr wrap="square" lIns="45720" rIns="45720" tIns="18288" bIns="18288" anchor="t">
-            <a:spAutoFit/>
-          </a:bodyPr>
-          <a:lstStyle/>
-          <a:p>
-            <a:pPr algn="l"/>
-            <a:r>
-              <a:rPr sz="1700" b="0" i="1">
-                <a:solidFill>
-                  <a:srgbClr val="6B6B6B"/>
-                </a:solidFill>
-                <a:latin typeface="Century Schoolbook"/>
-              </a:rPr>
-              <a:t>Boards up on three.</a:t>
-            </a:r>
-          </a:p>
-        </p:txBody>
-      </p:sp>
       <p:cxnSp>
         <p:nvCxnSpPr>
-          <p:cNvPr id="6" name="Connector 5"/>
+          <p:cNvPr id="5" name="Connector 4"/>
           <p:cNvCxnSpPr/>
           <p:nvPr/>
         </p:nvCxnSpPr>
@@ -8694,7 +7823,7 @@
       </p:cxnSp>
       <p:sp>
         <p:nvSpPr>
-          <p:cNvPr id="7" name="TextBox 6"/>
+          <p:cNvPr id="6" name="TextBox 5"/>
           <p:cNvSpPr txBox="1"/>
           <p:nvPr/>
         </p:nvSpPr>
@@ -8729,7 +7858,7 @@
       </p:sp>
       <p:sp>
         <p:nvSpPr>
-          <p:cNvPr id="8" name="TextBox 7"/>
+          <p:cNvPr id="7" name="TextBox 6"/>
           <p:cNvSpPr txBox="1"/>
           <p:nvPr/>
         </p:nvSpPr>
@@ -8764,7 +7893,7 @@
       </p:sp>
       <p:pic>
         <p:nvPicPr>
-          <p:cNvPr id="9" name="Picture 8" descr="c2285e954aff8d61.png"/>
+          <p:cNvPr id="8" name="Picture 7" descr="c2285e954aff8d61.png"/>
           <p:cNvPicPr>
             <a:picLocks noChangeAspect="1"/>
           </p:cNvPicPr>
@@ -8788,7 +7917,7 @@
       </p:pic>
       <p:sp>
         <p:nvSpPr>
-          <p:cNvPr id="10" name="TextBox 9"/>
+          <p:cNvPr id="9" name="TextBox 8"/>
           <p:cNvSpPr txBox="1"/>
           <p:nvPr/>
         </p:nvSpPr>
@@ -8817,41 +7946,6 @@
                 <a:latin typeface="Century Schoolbook"/>
               </a:rPr>
               <a:t>Answer it.</a:t>
-            </a:r>
-          </a:p>
-        </p:txBody>
-      </p:sp>
-      <p:sp>
-        <p:nvSpPr>
-          <p:cNvPr id="11" name="TextBox 10"/>
-          <p:cNvSpPr txBox="1"/>
-          <p:nvPr/>
-        </p:nvSpPr>
-        <p:spPr>
-          <a:xfrm>
-            <a:off x="777240" y="4828032"/>
-            <a:ext cx="10607040" cy="365760"/>
-          </a:xfrm>
-          <a:prstGeom prst="rect">
-            <a:avLst/>
-          </a:prstGeom>
-          <a:noFill/>
-        </p:spPr>
-        <p:txBody>
-          <a:bodyPr wrap="square" lIns="45720" rIns="45720" tIns="18288" bIns="18288" anchor="t">
-            <a:spAutoFit/>
-          </a:bodyPr>
-          <a:lstStyle/>
-          <a:p>
-            <a:pPr algn="ctr"/>
-            <a:r>
-              <a:rPr sz="1900" b="0" i="1">
-                <a:solidFill>
-                  <a:srgbClr val="6B6B6B"/>
-                </a:solidFill>
-                <a:latin typeface="Century Schoolbook"/>
-              </a:rPr>
-              <a:t>Rewrite with a positive exponent.</a:t>
             </a:r>
           </a:p>
         </p:txBody>
@@ -8979,44 +8073,9 @@
           </a:fontRef>
         </p:style>
       </p:cxnSp>
-      <p:sp>
-        <p:nvSpPr>
-          <p:cNvPr id="5" name="TextBox 4"/>
-          <p:cNvSpPr txBox="1"/>
-          <p:nvPr/>
-        </p:nvSpPr>
-        <p:spPr>
-          <a:xfrm>
-            <a:off x="777240" y="1261872"/>
-            <a:ext cx="10607040" cy="310896"/>
-          </a:xfrm>
-          <a:prstGeom prst="rect">
-            <a:avLst/>
-          </a:prstGeom>
-          <a:noFill/>
-        </p:spPr>
-        <p:txBody>
-          <a:bodyPr wrap="square" lIns="45720" rIns="45720" tIns="18288" bIns="18288" anchor="t">
-            <a:spAutoFit/>
-          </a:bodyPr>
-          <a:lstStyle/>
-          <a:p>
-            <a:pPr algn="l"/>
-            <a:r>
-              <a:rPr sz="1700" b="0" i="1">
-                <a:solidFill>
-                  <a:srgbClr val="6B6B6B"/>
-                </a:solidFill>
-                <a:latin typeface="Century Schoolbook"/>
-              </a:rPr>
-              <a:t>Answer.</a:t>
-            </a:r>
-          </a:p>
-        </p:txBody>
-      </p:sp>
       <p:cxnSp>
         <p:nvCxnSpPr>
-          <p:cNvPr id="6" name="Connector 5"/>
+          <p:cNvPr id="5" name="Connector 4"/>
           <p:cNvCxnSpPr/>
           <p:nvPr/>
         </p:nvCxnSpPr>
@@ -9051,7 +8110,7 @@
       </p:cxnSp>
       <p:sp>
         <p:nvSpPr>
-          <p:cNvPr id="7" name="TextBox 6"/>
+          <p:cNvPr id="6" name="TextBox 5"/>
           <p:cNvSpPr txBox="1"/>
           <p:nvPr/>
         </p:nvSpPr>
@@ -9086,7 +8145,7 @@
       </p:sp>
       <p:sp>
         <p:nvSpPr>
-          <p:cNvPr id="8" name="TextBox 7"/>
+          <p:cNvPr id="7" name="TextBox 6"/>
           <p:cNvSpPr txBox="1"/>
           <p:nvPr/>
         </p:nvSpPr>
@@ -9121,7 +8180,7 @@
       </p:sp>
       <p:pic>
         <p:nvPicPr>
-          <p:cNvPr id="9" name="Picture 8" descr="bf10b2e2dc356d3c.png"/>
+          <p:cNvPr id="8" name="Picture 7" descr="bf10b2e2dc356d3c.png"/>
           <p:cNvPicPr>
             <a:picLocks noChangeAspect="1"/>
           </p:cNvPicPr>
@@ -9145,42 +8204,7 @@
       </p:pic>
       <p:sp>
         <p:nvSpPr>
-          <p:cNvPr id="10" name="TextBox 9"/>
-          <p:cNvSpPr txBox="1"/>
-          <p:nvPr/>
-        </p:nvSpPr>
-        <p:spPr>
-          <a:xfrm>
-            <a:off x="1828800" y="3227832"/>
-            <a:ext cx="8503920" cy="548640"/>
-          </a:xfrm>
-          <a:prstGeom prst="rect">
-            <a:avLst/>
-          </a:prstGeom>
-          <a:noFill/>
-        </p:spPr>
-        <p:txBody>
-          <a:bodyPr wrap="square" lIns="45720" rIns="45720" tIns="18288" bIns="18288" anchor="t">
-            <a:spAutoFit/>
-          </a:bodyPr>
-          <a:lstStyle/>
-          <a:p>
-            <a:pPr algn="ctr"/>
-            <a:r>
-              <a:rPr sz="2400" b="0" i="0">
-                <a:solidFill>
-                  <a:srgbClr val="6B6B6B"/>
-                </a:solidFill>
-                <a:latin typeface="Century Schoolbook"/>
-              </a:rPr>
-              <a:t>flip</a:t>
-            </a:r>
-          </a:p>
-        </p:txBody>
-      </p:sp>
-      <p:sp>
-        <p:nvSpPr>
-          <p:cNvPr id="11" name="TextBox 10"/>
+          <p:cNvPr id="9" name="TextBox 8"/>
           <p:cNvSpPr txBox="1"/>
           <p:nvPr/>
         </p:nvSpPr>
@@ -9215,7 +8239,7 @@
       </p:sp>
       <p:pic>
         <p:nvPicPr>
-          <p:cNvPr id="12" name="Picture 11" descr="c2c7971114380740.png"/>
+          <p:cNvPr id="10" name="Picture 9" descr="c2c7971114380740.png"/>
           <p:cNvPicPr>
             <a:picLocks noChangeAspect="1"/>
           </p:cNvPicPr>
@@ -9360,44 +8384,9 @@
           </a:fontRef>
         </p:style>
       </p:cxnSp>
-      <p:sp>
-        <p:nvSpPr>
-          <p:cNvPr id="5" name="TextBox 4"/>
-          <p:cNvSpPr txBox="1"/>
-          <p:nvPr/>
-        </p:nvSpPr>
-        <p:spPr>
-          <a:xfrm>
-            <a:off x="777240" y="1261872"/>
-            <a:ext cx="10607040" cy="310896"/>
-          </a:xfrm>
-          <a:prstGeom prst="rect">
-            <a:avLst/>
-          </a:prstGeom>
-          <a:noFill/>
-        </p:spPr>
-        <p:txBody>
-          <a:bodyPr wrap="square" lIns="45720" rIns="45720" tIns="18288" bIns="18288" anchor="t">
-            <a:spAutoFit/>
-          </a:bodyPr>
-          <a:lstStyle/>
-          <a:p>
-            <a:pPr algn="l"/>
-            <a:r>
-              <a:rPr sz="1700" b="0" i="1">
-                <a:solidFill>
-                  <a:srgbClr val="6B6B6B"/>
-                </a:solidFill>
-                <a:latin typeface="Century Schoolbook"/>
-              </a:rPr>
-              <a:t>Boards up on three.</a:t>
-            </a:r>
-          </a:p>
-        </p:txBody>
-      </p:sp>
       <p:cxnSp>
         <p:nvCxnSpPr>
-          <p:cNvPr id="6" name="Connector 5"/>
+          <p:cNvPr id="5" name="Connector 4"/>
           <p:cNvCxnSpPr/>
           <p:nvPr/>
         </p:nvCxnSpPr>
@@ -9432,7 +8421,7 @@
       </p:cxnSp>
       <p:sp>
         <p:nvSpPr>
-          <p:cNvPr id="7" name="TextBox 6"/>
+          <p:cNvPr id="6" name="TextBox 5"/>
           <p:cNvSpPr txBox="1"/>
           <p:nvPr/>
         </p:nvSpPr>
@@ -9467,7 +8456,7 @@
       </p:sp>
       <p:sp>
         <p:nvSpPr>
-          <p:cNvPr id="8" name="TextBox 7"/>
+          <p:cNvPr id="7" name="TextBox 6"/>
           <p:cNvSpPr txBox="1"/>
           <p:nvPr/>
         </p:nvSpPr>
@@ -9502,7 +8491,7 @@
       </p:sp>
       <p:pic>
         <p:nvPicPr>
-          <p:cNvPr id="9" name="Picture 8" descr="fb95563de51335d3.png"/>
+          <p:cNvPr id="8" name="Picture 7" descr="fb95563de51335d3.png"/>
           <p:cNvPicPr>
             <a:picLocks noChangeAspect="1"/>
           </p:cNvPicPr>
@@ -9526,7 +8515,7 @@
       </p:pic>
       <p:sp>
         <p:nvSpPr>
-          <p:cNvPr id="10" name="TextBox 9"/>
+          <p:cNvPr id="9" name="TextBox 8"/>
           <p:cNvSpPr txBox="1"/>
           <p:nvPr/>
         </p:nvSpPr>
@@ -9561,7 +8550,7 @@
       </p:sp>
       <p:sp>
         <p:nvSpPr>
-          <p:cNvPr id="11" name="TextBox 10"/>
+          <p:cNvPr id="10" name="TextBox 9"/>
           <p:cNvSpPr txBox="1"/>
           <p:nvPr/>
         </p:nvSpPr>
@@ -9614,7 +8603,7 @@
       </p:sp>
       <p:sp>
         <p:nvSpPr>
-          <p:cNvPr id="12" name="TextBox 11"/>
+          <p:cNvPr id="11" name="TextBox 10"/>
           <p:cNvSpPr txBox="1"/>
           <p:nvPr/>
         </p:nvSpPr>
@@ -9667,7 +8656,7 @@
       </p:sp>
       <p:sp>
         <p:nvSpPr>
-          <p:cNvPr id="13" name="TextBox 12"/>
+          <p:cNvPr id="12" name="TextBox 11"/>
           <p:cNvSpPr txBox="1"/>
           <p:nvPr/>
         </p:nvSpPr>
@@ -9720,7 +8709,7 @@
       </p:sp>
       <p:sp>
         <p:nvSpPr>
-          <p:cNvPr id="14" name="TextBox 13"/>
+          <p:cNvPr id="13" name="TextBox 12"/>
           <p:cNvSpPr txBox="1"/>
           <p:nvPr/>
         </p:nvSpPr>
@@ -9773,7 +8762,7 @@
       </p:sp>
       <p:sp>
         <p:nvSpPr>
-          <p:cNvPr id="15" name="TextBox 14"/>
+          <p:cNvPr id="14" name="TextBox 13"/>
           <p:cNvSpPr txBox="1"/>
           <p:nvPr/>
         </p:nvSpPr>
@@ -9929,44 +8918,9 @@
           </a:fontRef>
         </p:style>
       </p:cxnSp>
-      <p:sp>
-        <p:nvSpPr>
-          <p:cNvPr id="5" name="TextBox 4"/>
-          <p:cNvSpPr txBox="1"/>
-          <p:nvPr/>
-        </p:nvSpPr>
-        <p:spPr>
-          <a:xfrm>
-            <a:off x="777240" y="1261872"/>
-            <a:ext cx="10607040" cy="310896"/>
-          </a:xfrm>
-          <a:prstGeom prst="rect">
-            <a:avLst/>
-          </a:prstGeom>
-          <a:noFill/>
-        </p:spPr>
-        <p:txBody>
-          <a:bodyPr wrap="square" lIns="45720" rIns="45720" tIns="18288" bIns="18288" anchor="t">
-            <a:spAutoFit/>
-          </a:bodyPr>
-          <a:lstStyle/>
-          <a:p>
-            <a:pPr algn="l"/>
-            <a:r>
-              <a:rPr sz="1700" b="0" i="1">
-                <a:solidFill>
-                  <a:srgbClr val="6B6B6B"/>
-                </a:solidFill>
-                <a:latin typeface="Century Schoolbook"/>
-              </a:rPr>
-              <a:t>Answer.</a:t>
-            </a:r>
-          </a:p>
-        </p:txBody>
-      </p:sp>
       <p:cxnSp>
         <p:nvCxnSpPr>
-          <p:cNvPr id="6" name="Connector 5"/>
+          <p:cNvPr id="5" name="Connector 4"/>
           <p:cNvCxnSpPr/>
           <p:nvPr/>
         </p:nvCxnSpPr>
@@ -10001,7 +8955,7 @@
       </p:cxnSp>
       <p:sp>
         <p:nvSpPr>
-          <p:cNvPr id="7" name="TextBox 6"/>
+          <p:cNvPr id="6" name="TextBox 5"/>
           <p:cNvSpPr txBox="1"/>
           <p:nvPr/>
         </p:nvSpPr>
@@ -10036,7 +8990,7 @@
       </p:sp>
       <p:sp>
         <p:nvSpPr>
-          <p:cNvPr id="8" name="TextBox 7"/>
+          <p:cNvPr id="7" name="TextBox 6"/>
           <p:cNvSpPr txBox="1"/>
           <p:nvPr/>
         </p:nvSpPr>
@@ -10071,7 +9025,7 @@
       </p:sp>
       <p:pic>
         <p:nvPicPr>
-          <p:cNvPr id="9" name="Picture 8" descr="de3072ed6d5fe593.png"/>
+          <p:cNvPr id="8" name="Picture 7" descr="de3072ed6d5fe593.png"/>
           <p:cNvPicPr>
             <a:picLocks noChangeAspect="1"/>
           </p:cNvPicPr>
@@ -10095,7 +9049,7 @@
       </p:pic>
       <p:sp>
         <p:nvSpPr>
-          <p:cNvPr id="10" name="TextBox 9"/>
+          <p:cNvPr id="9" name="TextBox 8"/>
           <p:cNvSpPr txBox="1"/>
           <p:nvPr/>
         </p:nvSpPr>
@@ -10130,7 +9084,7 @@
       </p:sp>
       <p:sp>
         <p:nvSpPr>
-          <p:cNvPr id="11" name="TextBox 10"/>
+          <p:cNvPr id="10" name="TextBox 9"/>
           <p:cNvSpPr txBox="1"/>
           <p:nvPr/>
         </p:nvSpPr>
@@ -10183,7 +9137,7 @@
       </p:sp>
       <p:sp>
         <p:nvSpPr>
-          <p:cNvPr id="12" name="TextBox 11"/>
+          <p:cNvPr id="11" name="TextBox 10"/>
           <p:cNvSpPr txBox="1"/>
           <p:nvPr/>
         </p:nvSpPr>
@@ -10236,7 +9190,7 @@
       </p:sp>
       <p:sp>
         <p:nvSpPr>
-          <p:cNvPr id="13" name="TextBox 12"/>
+          <p:cNvPr id="12" name="TextBox 11"/>
           <p:cNvSpPr txBox="1"/>
           <p:nvPr/>
         </p:nvSpPr>
@@ -10289,7 +9243,7 @@
       </p:sp>
       <p:sp>
         <p:nvSpPr>
-          <p:cNvPr id="14" name="TextBox 13"/>
+          <p:cNvPr id="13" name="TextBox 12"/>
           <p:cNvSpPr txBox="1"/>
           <p:nvPr/>
         </p:nvSpPr>
@@ -10342,7 +9296,7 @@
       </p:sp>
       <p:sp>
         <p:nvSpPr>
-          <p:cNvPr id="15" name="TextBox 14"/>
+          <p:cNvPr id="14" name="TextBox 13"/>
           <p:cNvSpPr txBox="1"/>
           <p:nvPr/>
         </p:nvSpPr>
@@ -10507,44 +9461,9 @@
           </a:fontRef>
         </p:style>
       </p:cxnSp>
-      <p:sp>
-        <p:nvSpPr>
-          <p:cNvPr id="5" name="TextBox 4"/>
-          <p:cNvSpPr txBox="1"/>
-          <p:nvPr/>
-        </p:nvSpPr>
-        <p:spPr>
-          <a:xfrm>
-            <a:off x="777240" y="1261872"/>
-            <a:ext cx="10607040" cy="310896"/>
-          </a:xfrm>
-          <a:prstGeom prst="rect">
-            <a:avLst/>
-          </a:prstGeom>
-          <a:noFill/>
-        </p:spPr>
-        <p:txBody>
-          <a:bodyPr wrap="square" lIns="45720" rIns="45720" tIns="18288" bIns="18288" anchor="t">
-            <a:spAutoFit/>
-          </a:bodyPr>
-          <a:lstStyle/>
-          <a:p>
-            <a:pPr algn="l"/>
-            <a:r>
-              <a:rPr sz="1700" b="0" i="1">
-                <a:solidFill>
-                  <a:srgbClr val="6B6B6B"/>
-                </a:solidFill>
-                <a:latin typeface="Century Schoolbook"/>
-              </a:rPr>
-              <a:t>Boards up on three.</a:t>
-            </a:r>
-          </a:p>
-        </p:txBody>
-      </p:sp>
       <p:cxnSp>
         <p:nvCxnSpPr>
-          <p:cNvPr id="6" name="Connector 5"/>
+          <p:cNvPr id="5" name="Connector 4"/>
           <p:cNvCxnSpPr/>
           <p:nvPr/>
         </p:nvCxnSpPr>
@@ -10579,7 +9498,7 @@
       </p:cxnSp>
       <p:sp>
         <p:nvSpPr>
-          <p:cNvPr id="7" name="TextBox 6"/>
+          <p:cNvPr id="6" name="TextBox 5"/>
           <p:cNvSpPr txBox="1"/>
           <p:nvPr/>
         </p:nvSpPr>
@@ -10614,7 +9533,7 @@
       </p:sp>
       <p:sp>
         <p:nvSpPr>
-          <p:cNvPr id="8" name="TextBox 7"/>
+          <p:cNvPr id="7" name="TextBox 6"/>
           <p:cNvSpPr txBox="1"/>
           <p:nvPr/>
         </p:nvSpPr>
@@ -10649,7 +9568,7 @@
       </p:sp>
       <p:pic>
         <p:nvPicPr>
-          <p:cNvPr id="9" name="Picture 8" descr="e9242358ed1b2b8f.png"/>
+          <p:cNvPr id="8" name="Picture 7" descr="e9242358ed1b2b8f.png"/>
           <p:cNvPicPr>
             <a:picLocks noChangeAspect="1"/>
           </p:cNvPicPr>
@@ -10673,7 +9592,7 @@
       </p:pic>
       <p:sp>
         <p:nvSpPr>
-          <p:cNvPr id="10" name="TextBox 9"/>
+          <p:cNvPr id="9" name="TextBox 8"/>
           <p:cNvSpPr txBox="1"/>
           <p:nvPr/>
         </p:nvSpPr>
@@ -10708,7 +9627,7 @@
       </p:sp>
       <p:sp>
         <p:nvSpPr>
-          <p:cNvPr id="11" name="TextBox 10"/>
+          <p:cNvPr id="10" name="TextBox 9"/>
           <p:cNvSpPr txBox="1"/>
           <p:nvPr/>
         </p:nvSpPr>
@@ -10761,7 +9680,7 @@
       </p:sp>
       <p:sp>
         <p:nvSpPr>
-          <p:cNvPr id="12" name="TextBox 11"/>
+          <p:cNvPr id="11" name="TextBox 10"/>
           <p:cNvSpPr txBox="1"/>
           <p:nvPr/>
         </p:nvSpPr>
@@ -10814,7 +9733,7 @@
       </p:sp>
       <p:sp>
         <p:nvSpPr>
-          <p:cNvPr id="13" name="TextBox 12"/>
+          <p:cNvPr id="12" name="TextBox 11"/>
           <p:cNvSpPr txBox="1"/>
           <p:nvPr/>
         </p:nvSpPr>
@@ -10867,7 +9786,7 @@
       </p:sp>
       <p:sp>
         <p:nvSpPr>
-          <p:cNvPr id="14" name="TextBox 13"/>
+          <p:cNvPr id="13" name="TextBox 12"/>
           <p:cNvSpPr txBox="1"/>
           <p:nvPr/>
         </p:nvSpPr>
@@ -10920,7 +9839,7 @@
       </p:sp>
       <p:sp>
         <p:nvSpPr>
-          <p:cNvPr id="15" name="TextBox 14"/>
+          <p:cNvPr id="14" name="TextBox 13"/>
           <p:cNvSpPr txBox="1"/>
           <p:nvPr/>
         </p:nvSpPr>
@@ -11076,44 +9995,9 @@
           </a:fontRef>
         </p:style>
       </p:cxnSp>
-      <p:sp>
-        <p:nvSpPr>
-          <p:cNvPr id="5" name="TextBox 4"/>
-          <p:cNvSpPr txBox="1"/>
-          <p:nvPr/>
-        </p:nvSpPr>
-        <p:spPr>
-          <a:xfrm>
-            <a:off x="777240" y="1261872"/>
-            <a:ext cx="10607040" cy="310896"/>
-          </a:xfrm>
-          <a:prstGeom prst="rect">
-            <a:avLst/>
-          </a:prstGeom>
-          <a:noFill/>
-        </p:spPr>
-        <p:txBody>
-          <a:bodyPr wrap="square" lIns="45720" rIns="45720" tIns="18288" bIns="18288" anchor="t">
-            <a:spAutoFit/>
-          </a:bodyPr>
-          <a:lstStyle/>
-          <a:p>
-            <a:pPr algn="l"/>
-            <a:r>
-              <a:rPr sz="1700" b="0" i="1">
-                <a:solidFill>
-                  <a:srgbClr val="6B6B6B"/>
-                </a:solidFill>
-                <a:latin typeface="Century Schoolbook"/>
-              </a:rPr>
-              <a:t>Answer.</a:t>
-            </a:r>
-          </a:p>
-        </p:txBody>
-      </p:sp>
       <p:cxnSp>
         <p:nvCxnSpPr>
-          <p:cNvPr id="6" name="Connector 5"/>
+          <p:cNvPr id="5" name="Connector 4"/>
           <p:cNvCxnSpPr/>
           <p:nvPr/>
         </p:nvCxnSpPr>
@@ -11148,7 +10032,7 @@
       </p:cxnSp>
       <p:sp>
         <p:nvSpPr>
-          <p:cNvPr id="7" name="TextBox 6"/>
+          <p:cNvPr id="6" name="TextBox 5"/>
           <p:cNvSpPr txBox="1"/>
           <p:nvPr/>
         </p:nvSpPr>
@@ -11183,7 +10067,7 @@
       </p:sp>
       <p:sp>
         <p:nvSpPr>
-          <p:cNvPr id="8" name="TextBox 7"/>
+          <p:cNvPr id="7" name="TextBox 6"/>
           <p:cNvSpPr txBox="1"/>
           <p:nvPr/>
         </p:nvSpPr>
@@ -11218,7 +10102,7 @@
       </p:sp>
       <p:pic>
         <p:nvPicPr>
-          <p:cNvPr id="9" name="Picture 8" descr="77243053f2f7c3fe.png"/>
+          <p:cNvPr id="8" name="Picture 7" descr="77243053f2f7c3fe.png"/>
           <p:cNvPicPr>
             <a:picLocks noChangeAspect="1"/>
           </p:cNvPicPr>
@@ -11242,7 +10126,7 @@
       </p:pic>
       <p:sp>
         <p:nvSpPr>
-          <p:cNvPr id="10" name="TextBox 9"/>
+          <p:cNvPr id="9" name="TextBox 8"/>
           <p:cNvSpPr txBox="1"/>
           <p:nvPr/>
         </p:nvSpPr>
@@ -11277,7 +10161,7 @@
       </p:sp>
       <p:sp>
         <p:nvSpPr>
-          <p:cNvPr id="11" name="TextBox 10"/>
+          <p:cNvPr id="10" name="TextBox 9"/>
           <p:cNvSpPr txBox="1"/>
           <p:nvPr/>
         </p:nvSpPr>
@@ -11330,7 +10214,7 @@
       </p:sp>
       <p:sp>
         <p:nvSpPr>
-          <p:cNvPr id="12" name="TextBox 11"/>
+          <p:cNvPr id="11" name="TextBox 10"/>
           <p:cNvSpPr txBox="1"/>
           <p:nvPr/>
         </p:nvSpPr>
@@ -11383,7 +10267,7 @@
       </p:sp>
       <p:sp>
         <p:nvSpPr>
-          <p:cNvPr id="13" name="TextBox 12"/>
+          <p:cNvPr id="12" name="TextBox 11"/>
           <p:cNvSpPr txBox="1"/>
           <p:nvPr/>
         </p:nvSpPr>
@@ -11436,7 +10320,7 @@
       </p:sp>
       <p:sp>
         <p:nvSpPr>
-          <p:cNvPr id="14" name="TextBox 13"/>
+          <p:cNvPr id="13" name="TextBox 12"/>
           <p:cNvSpPr txBox="1"/>
           <p:nvPr/>
         </p:nvSpPr>
@@ -11489,7 +10373,7 @@
       </p:sp>
       <p:sp>
         <p:nvSpPr>
-          <p:cNvPr id="15" name="TextBox 14"/>
+          <p:cNvPr id="14" name="TextBox 13"/>
           <p:cNvSpPr txBox="1"/>
           <p:nvPr/>
         </p:nvSpPr>
@@ -11654,44 +10538,9 @@
           </a:fontRef>
         </p:style>
       </p:cxnSp>
-      <p:sp>
-        <p:nvSpPr>
-          <p:cNvPr id="5" name="TextBox 4"/>
-          <p:cNvSpPr txBox="1"/>
-          <p:nvPr/>
-        </p:nvSpPr>
-        <p:spPr>
-          <a:xfrm>
-            <a:off x="777240" y="1261872"/>
-            <a:ext cx="10607040" cy="310896"/>
-          </a:xfrm>
-          <a:prstGeom prst="rect">
-            <a:avLst/>
-          </a:prstGeom>
-          <a:noFill/>
-        </p:spPr>
-        <p:txBody>
-          <a:bodyPr wrap="square" lIns="45720" rIns="45720" tIns="18288" bIns="18288" anchor="t">
-            <a:spAutoFit/>
-          </a:bodyPr>
-          <a:lstStyle/>
-          <a:p>
-            <a:pPr algn="l"/>
-            <a:r>
-              <a:rPr sz="1700" b="0" i="1">
-                <a:solidFill>
-                  <a:srgbClr val="6B6B6B"/>
-                </a:solidFill>
-                <a:latin typeface="Century Schoolbook"/>
-              </a:rPr>
-              <a:t>Boards up on three.</a:t>
-            </a:r>
-          </a:p>
-        </p:txBody>
-      </p:sp>
       <p:cxnSp>
         <p:nvCxnSpPr>
-          <p:cNvPr id="6" name="Connector 5"/>
+          <p:cNvPr id="5" name="Connector 4"/>
           <p:cNvCxnSpPr/>
           <p:nvPr/>
         </p:nvCxnSpPr>
@@ -11726,7 +10575,7 @@
       </p:cxnSp>
       <p:sp>
         <p:nvSpPr>
-          <p:cNvPr id="7" name="TextBox 6"/>
+          <p:cNvPr id="6" name="TextBox 5"/>
           <p:cNvSpPr txBox="1"/>
           <p:nvPr/>
         </p:nvSpPr>
@@ -11761,7 +10610,7 @@
       </p:sp>
       <p:sp>
         <p:nvSpPr>
-          <p:cNvPr id="8" name="TextBox 7"/>
+          <p:cNvPr id="7" name="TextBox 6"/>
           <p:cNvSpPr txBox="1"/>
           <p:nvPr/>
         </p:nvSpPr>
@@ -11796,7 +10645,7 @@
       </p:sp>
       <p:pic>
         <p:nvPicPr>
-          <p:cNvPr id="9" name="Picture 8" descr="983316d8a340e399.png"/>
+          <p:cNvPr id="8" name="Picture 7" descr="983316d8a340e399.png"/>
           <p:cNvPicPr>
             <a:picLocks noChangeAspect="1"/>
           </p:cNvPicPr>
@@ -11820,7 +10669,7 @@
       </p:pic>
       <p:sp>
         <p:nvSpPr>
-          <p:cNvPr id="10" name="TextBox 9"/>
+          <p:cNvPr id="9" name="TextBox 8"/>
           <p:cNvSpPr txBox="1"/>
           <p:nvPr/>
         </p:nvSpPr>
@@ -11849,41 +10698,6 @@
                 <a:latin typeface="Century Schoolbook"/>
               </a:rPr>
               <a:t>Answer it.</a:t>
-            </a:r>
-          </a:p>
-        </p:txBody>
-      </p:sp>
-      <p:sp>
-        <p:nvSpPr>
-          <p:cNvPr id="11" name="TextBox 10"/>
-          <p:cNvSpPr txBox="1"/>
-          <p:nvPr/>
-        </p:nvSpPr>
-        <p:spPr>
-          <a:xfrm>
-            <a:off x="777240" y="4828032"/>
-            <a:ext cx="10607040" cy="365760"/>
-          </a:xfrm>
-          <a:prstGeom prst="rect">
-            <a:avLst/>
-          </a:prstGeom>
-          <a:noFill/>
-        </p:spPr>
-        <p:txBody>
-          <a:bodyPr wrap="square" lIns="45720" rIns="45720" tIns="18288" bIns="18288" anchor="t">
-            <a:spAutoFit/>
-          </a:bodyPr>
-          <a:lstStyle/>
-          <a:p>
-            <a:pPr algn="ctr"/>
-            <a:r>
-              <a:rPr sz="1900" b="0" i="1">
-                <a:solidFill>
-                  <a:srgbClr val="6B6B6B"/>
-                </a:solidFill>
-                <a:latin typeface="Century Schoolbook"/>
-              </a:rPr>
-              <a:t>Find the value.</a:t>
             </a:r>
           </a:p>
         </p:txBody>
@@ -12011,44 +10825,9 @@
           </a:fontRef>
         </p:style>
       </p:cxnSp>
-      <p:sp>
-        <p:nvSpPr>
-          <p:cNvPr id="5" name="TextBox 4"/>
-          <p:cNvSpPr txBox="1"/>
-          <p:nvPr/>
-        </p:nvSpPr>
-        <p:spPr>
-          <a:xfrm>
-            <a:off x="777240" y="1261872"/>
-            <a:ext cx="10607040" cy="310896"/>
-          </a:xfrm>
-          <a:prstGeom prst="rect">
-            <a:avLst/>
-          </a:prstGeom>
-          <a:noFill/>
-        </p:spPr>
-        <p:txBody>
-          <a:bodyPr wrap="square" lIns="45720" rIns="45720" tIns="18288" bIns="18288" anchor="t">
-            <a:spAutoFit/>
-          </a:bodyPr>
-          <a:lstStyle/>
-          <a:p>
-            <a:pPr algn="l"/>
-            <a:r>
-              <a:rPr sz="1700" b="0" i="1">
-                <a:solidFill>
-                  <a:srgbClr val="6B6B6B"/>
-                </a:solidFill>
-                <a:latin typeface="Century Schoolbook"/>
-              </a:rPr>
-              <a:t>Answer.</a:t>
-            </a:r>
-          </a:p>
-        </p:txBody>
-      </p:sp>
       <p:cxnSp>
         <p:nvCxnSpPr>
-          <p:cNvPr id="6" name="Connector 5"/>
+          <p:cNvPr id="5" name="Connector 4"/>
           <p:cNvCxnSpPr/>
           <p:nvPr/>
         </p:nvCxnSpPr>
@@ -12083,7 +10862,7 @@
       </p:cxnSp>
       <p:sp>
         <p:nvSpPr>
-          <p:cNvPr id="7" name="TextBox 6"/>
+          <p:cNvPr id="6" name="TextBox 5"/>
           <p:cNvSpPr txBox="1"/>
           <p:nvPr/>
         </p:nvSpPr>
@@ -12118,7 +10897,7 @@
       </p:sp>
       <p:sp>
         <p:nvSpPr>
-          <p:cNvPr id="8" name="TextBox 7"/>
+          <p:cNvPr id="7" name="TextBox 6"/>
           <p:cNvSpPr txBox="1"/>
           <p:nvPr/>
         </p:nvSpPr>
@@ -12153,7 +10932,7 @@
       </p:sp>
       <p:pic>
         <p:nvPicPr>
-          <p:cNvPr id="9" name="Picture 8" descr="cccf2e6aacb49bf9.png"/>
+          <p:cNvPr id="8" name="Picture 7" descr="cccf2e6aacb49bf9.png"/>
           <p:cNvPicPr>
             <a:picLocks noChangeAspect="1"/>
           </p:cNvPicPr>
@@ -12177,87 +10956,7 @@
       </p:pic>
       <p:sp>
         <p:nvSpPr>
-          <p:cNvPr id="10" name="TextBox 9"/>
-          <p:cNvSpPr txBox="1"/>
-          <p:nvPr/>
-        </p:nvSpPr>
-        <p:spPr>
-          <a:xfrm>
-            <a:off x="1828800" y="3255263"/>
-            <a:ext cx="8503920" cy="548640"/>
-          </a:xfrm>
-          <a:prstGeom prst="rect">
-            <a:avLst/>
-          </a:prstGeom>
-          <a:noFill/>
-        </p:spPr>
-        <p:txBody>
-          <a:bodyPr wrap="square" lIns="45720" rIns="45720" tIns="18288" bIns="18288" anchor="t">
-            <a:spAutoFit/>
-          </a:bodyPr>
-          <a:lstStyle/>
-          <a:p>
-            <a:pPr algn="ctr"/>
-            <a:r>
-              <a:rPr sz="2400" b="0" i="0">
-                <a:solidFill>
-                  <a:srgbClr val="6B6B6B"/>
-                </a:solidFill>
-                <a:latin typeface="Century Schoolbook"/>
-              </a:rPr>
-              <a:t>(5/2)</a:t>
-            </a:r>
-            <a:r>
-              <a:rPr sz="2400" b="0" i="0" baseline="30000">
-                <a:solidFill>
-                  <a:srgbClr val="6B6B6B"/>
-                </a:solidFill>
-                <a:latin typeface="Century Schoolbook"/>
-              </a:rPr>
-              <a:t>1</a:t>
-            </a:r>
-            <a:r>
-              <a:rPr sz="2400" b="0" i="0">
-                <a:solidFill>
-                  <a:srgbClr val="6B6B6B"/>
-                </a:solidFill>
-                <a:latin typeface="Century Schoolbook"/>
-              </a:rPr>
-              <a:t> · (5/2)</a:t>
-            </a:r>
-            <a:r>
-              <a:rPr sz="2400" b="0" i="0" baseline="30000">
-                <a:solidFill>
-                  <a:srgbClr val="6B6B6B"/>
-                </a:solidFill>
-                <a:latin typeface="Century Schoolbook"/>
-              </a:rPr>
-              <a:t>1</a:t>
-            </a:r>
-            <a:r>
-              <a:rPr sz="2400" b="0" i="0">
-                <a:solidFill>
-                  <a:srgbClr val="6B6B6B"/>
-                </a:solidFill>
-                <a:latin typeface="Century Schoolbook"/>
-              </a:rPr>
-              <a:t> = (5/2)</a:t>
-            </a:r>
-            <a:r>
-              <a:rPr sz="2400" b="0" i="0" baseline="30000">
-                <a:solidFill>
-                  <a:srgbClr val="6B6B6B"/>
-                </a:solidFill>
-                <a:latin typeface="Century Schoolbook"/>
-              </a:rPr>
-              <a:t>2</a:t>
-            </a:r>
-          </a:p>
-        </p:txBody>
-      </p:sp>
-      <p:sp>
-        <p:nvSpPr>
-          <p:cNvPr id="11" name="TextBox 10"/>
+          <p:cNvPr id="9" name="TextBox 8"/>
           <p:cNvSpPr txBox="1"/>
           <p:nvPr/>
         </p:nvSpPr>
@@ -12292,7 +10991,7 @@
       </p:sp>
       <p:pic>
         <p:nvPicPr>
-          <p:cNvPr id="12" name="Picture 11" descr="c37c2f03a9ba8642.png"/>
+          <p:cNvPr id="10" name="Picture 9" descr="c37c2f03a9ba8642.png"/>
           <p:cNvPicPr>
             <a:picLocks noChangeAspect="1"/>
           </p:cNvPicPr>
@@ -12437,44 +11136,9 @@
           </a:fontRef>
         </p:style>
       </p:cxnSp>
-      <p:sp>
-        <p:nvSpPr>
-          <p:cNvPr id="5" name="TextBox 4"/>
-          <p:cNvSpPr txBox="1"/>
-          <p:nvPr/>
-        </p:nvSpPr>
-        <p:spPr>
-          <a:xfrm>
-            <a:off x="777240" y="1261872"/>
-            <a:ext cx="10607040" cy="310896"/>
-          </a:xfrm>
-          <a:prstGeom prst="rect">
-            <a:avLst/>
-          </a:prstGeom>
-          <a:noFill/>
-        </p:spPr>
-        <p:txBody>
-          <a:bodyPr wrap="square" lIns="45720" rIns="45720" tIns="18288" bIns="18288" anchor="t">
-            <a:spAutoFit/>
-          </a:bodyPr>
-          <a:lstStyle/>
-          <a:p>
-            <a:pPr algn="l"/>
-            <a:r>
-              <a:rPr sz="1700" b="0" i="1">
-                <a:solidFill>
-                  <a:srgbClr val="6B6B6B"/>
-                </a:solidFill>
-                <a:latin typeface="Century Schoolbook"/>
-              </a:rPr>
-              <a:t>Boards up on three.</a:t>
-            </a:r>
-          </a:p>
-        </p:txBody>
-      </p:sp>
       <p:cxnSp>
         <p:nvCxnSpPr>
-          <p:cNvPr id="6" name="Connector 5"/>
+          <p:cNvPr id="5" name="Connector 4"/>
           <p:cNvCxnSpPr/>
           <p:nvPr/>
         </p:nvCxnSpPr>
@@ -12509,7 +11173,7 @@
       </p:cxnSp>
       <p:sp>
         <p:nvSpPr>
-          <p:cNvPr id="7" name="TextBox 6"/>
+          <p:cNvPr id="6" name="TextBox 5"/>
           <p:cNvSpPr txBox="1"/>
           <p:nvPr/>
         </p:nvSpPr>
@@ -12544,7 +11208,7 @@
       </p:sp>
       <p:sp>
         <p:nvSpPr>
-          <p:cNvPr id="8" name="TextBox 7"/>
+          <p:cNvPr id="7" name="TextBox 6"/>
           <p:cNvSpPr txBox="1"/>
           <p:nvPr/>
         </p:nvSpPr>
@@ -12579,7 +11243,7 @@
       </p:sp>
       <p:pic>
         <p:nvPicPr>
-          <p:cNvPr id="9" name="Picture 8" descr="c18abdc6135bde12.png"/>
+          <p:cNvPr id="8" name="Picture 7" descr="c18abdc6135bde12.png"/>
           <p:cNvPicPr>
             <a:picLocks noChangeAspect="1"/>
           </p:cNvPicPr>
@@ -12603,7 +11267,7 @@
       </p:pic>
       <p:sp>
         <p:nvSpPr>
-          <p:cNvPr id="10" name="TextBox 9"/>
+          <p:cNvPr id="9" name="TextBox 8"/>
           <p:cNvSpPr txBox="1"/>
           <p:nvPr/>
         </p:nvSpPr>
@@ -12632,41 +11296,6 @@
                 <a:latin typeface="Century Schoolbook"/>
               </a:rPr>
               <a:t>Answer it.</a:t>
-            </a:r>
-          </a:p>
-        </p:txBody>
-      </p:sp>
-      <p:sp>
-        <p:nvSpPr>
-          <p:cNvPr id="11" name="TextBox 10"/>
-          <p:cNvSpPr txBox="1"/>
-          <p:nvPr/>
-        </p:nvSpPr>
-        <p:spPr>
-          <a:xfrm>
-            <a:off x="777240" y="4828032"/>
-            <a:ext cx="10607040" cy="365760"/>
-          </a:xfrm>
-          <a:prstGeom prst="rect">
-            <a:avLst/>
-          </a:prstGeom>
-          <a:noFill/>
-        </p:spPr>
-        <p:txBody>
-          <a:bodyPr wrap="square" lIns="45720" rIns="45720" tIns="18288" bIns="18288" anchor="t">
-            <a:spAutoFit/>
-          </a:bodyPr>
-          <a:lstStyle/>
-          <a:p>
-            <a:pPr algn="ctr"/>
-            <a:r>
-              <a:rPr sz="1900" b="0" i="1">
-                <a:solidFill>
-                  <a:srgbClr val="6B6B6B"/>
-                </a:solidFill>
-                <a:latin typeface="Century Schoolbook"/>
-              </a:rPr>
-              <a:t>Write it with one base and one positive exponent.</a:t>
             </a:r>
           </a:p>
         </p:txBody>
@@ -12794,44 +11423,9 @@
           </a:fontRef>
         </p:style>
       </p:cxnSp>
-      <p:sp>
-        <p:nvSpPr>
-          <p:cNvPr id="5" name="TextBox 4"/>
-          <p:cNvSpPr txBox="1"/>
-          <p:nvPr/>
-        </p:nvSpPr>
-        <p:spPr>
-          <a:xfrm>
-            <a:off x="777240" y="1261872"/>
-            <a:ext cx="10607040" cy="310896"/>
-          </a:xfrm>
-          <a:prstGeom prst="rect">
-            <a:avLst/>
-          </a:prstGeom>
-          <a:noFill/>
-        </p:spPr>
-        <p:txBody>
-          <a:bodyPr wrap="square" lIns="45720" rIns="45720" tIns="18288" bIns="18288" anchor="t">
-            <a:spAutoFit/>
-          </a:bodyPr>
-          <a:lstStyle/>
-          <a:p>
-            <a:pPr algn="l"/>
-            <a:r>
-              <a:rPr sz="1700" b="0" i="1">
-                <a:solidFill>
-                  <a:srgbClr val="6B6B6B"/>
-                </a:solidFill>
-                <a:latin typeface="Century Schoolbook"/>
-              </a:rPr>
-              <a:t>Answers.</a:t>
-            </a:r>
-          </a:p>
-        </p:txBody>
-      </p:sp>
       <p:cxnSp>
         <p:nvCxnSpPr>
-          <p:cNvPr id="6" name="Connector 5"/>
+          <p:cNvPr id="5" name="Connector 4"/>
           <p:cNvCxnSpPr/>
           <p:nvPr/>
         </p:nvCxnSpPr>
@@ -12866,7 +11460,7 @@
       </p:cxnSp>
       <p:sp>
         <p:nvSpPr>
-          <p:cNvPr id="7" name="TextBox 6"/>
+          <p:cNvPr id="6" name="TextBox 5"/>
           <p:cNvSpPr txBox="1"/>
           <p:nvPr/>
         </p:nvSpPr>
@@ -12901,7 +11495,7 @@
       </p:sp>
       <p:sp>
         <p:nvSpPr>
-          <p:cNvPr id="8" name="TextBox 7"/>
+          <p:cNvPr id="7" name="TextBox 6"/>
           <p:cNvSpPr txBox="1"/>
           <p:nvPr/>
         </p:nvSpPr>
@@ -12936,13 +11530,13 @@
       </p:sp>
       <p:sp>
         <p:nvSpPr>
-          <p:cNvPr id="9" name="TextBox 8"/>
-          <p:cNvSpPr txBox="1"/>
-          <p:nvPr/>
-        </p:nvSpPr>
-        <p:spPr>
-          <a:xfrm>
-            <a:off x="1874519" y="1760220"/>
+          <p:cNvPr id="8" name="TextBox 7"/>
+          <p:cNvSpPr txBox="1"/>
+          <p:nvPr/>
+        </p:nvSpPr>
+        <p:spPr>
+          <a:xfrm>
+            <a:off x="1874519" y="1440180"/>
             <a:ext cx="3058734" cy="457200"/>
           </a:xfrm>
           <a:prstGeom prst="rect">
@@ -12971,7 +11565,7 @@
       </p:sp>
       <p:pic>
         <p:nvPicPr>
-          <p:cNvPr id="10" name="Picture 9" descr="1538ef9a323bca44.png"/>
+          <p:cNvPr id="9" name="Picture 8" descr="1538ef9a323bca44.png"/>
           <p:cNvPicPr>
             <a:picLocks noChangeAspect="1"/>
           </p:cNvPicPr>
@@ -12985,7 +11579,7 @@
         </p:blipFill>
         <p:spPr>
           <a:xfrm>
-            <a:off x="4796094" y="1851660"/>
+            <a:off x="4796094" y="1531620"/>
             <a:ext cx="417576" cy="274320"/>
           </a:xfrm>
           <a:prstGeom prst="rect">
@@ -12995,7 +11589,7 @@
       </p:pic>
       <p:pic>
         <p:nvPicPr>
-          <p:cNvPr id="11" name="Picture 10" descr="0f45754c59884ba0.png"/>
+          <p:cNvPr id="10" name="Picture 9" descr="0f45754c59884ba0.png"/>
           <p:cNvPicPr>
             <a:picLocks noChangeAspect="1"/>
           </p:cNvPicPr>
@@ -13009,7 +11603,7 @@
         </p:blipFill>
         <p:spPr>
           <a:xfrm>
-            <a:off x="5762310" y="1783080"/>
+            <a:off x="5762310" y="1463040"/>
             <a:ext cx="170688" cy="554736"/>
           </a:xfrm>
           <a:prstGeom prst="rect">
@@ -13019,13 +11613,13 @@
       </p:pic>
       <p:sp>
         <p:nvSpPr>
-          <p:cNvPr id="12" name="TextBox 11"/>
-          <p:cNvSpPr txBox="1"/>
-          <p:nvPr/>
-        </p:nvSpPr>
-        <p:spPr>
-          <a:xfrm>
-            <a:off x="1874519" y="2468880"/>
+          <p:cNvPr id="11" name="TextBox 10"/>
+          <p:cNvSpPr txBox="1"/>
+          <p:nvPr/>
+        </p:nvSpPr>
+        <p:spPr>
+          <a:xfrm>
+            <a:off x="1874519" y="2148840"/>
             <a:ext cx="5677198" cy="457200"/>
           </a:xfrm>
           <a:prstGeom prst="rect">
@@ -13054,7 +11648,7 @@
       </p:sp>
       <p:pic>
         <p:nvPicPr>
-          <p:cNvPr id="13" name="Picture 12" descr="82be0161615a5d7f.png"/>
+          <p:cNvPr id="12" name="Picture 11" descr="82be0161615a5d7f.png"/>
           <p:cNvPicPr>
             <a:picLocks noChangeAspect="1"/>
           </p:cNvPicPr>
@@ -13068,7 +11662,7 @@
         </p:blipFill>
         <p:spPr>
           <a:xfrm>
-            <a:off x="7414558" y="2395728"/>
+            <a:off x="7414558" y="2075688"/>
             <a:ext cx="463296" cy="603504"/>
           </a:xfrm>
           <a:prstGeom prst="rect">
@@ -13078,7 +11672,7 @@
       </p:pic>
       <p:pic>
         <p:nvPicPr>
-          <p:cNvPr id="14" name="Picture 13" descr="b031d4b8beeb8414.png"/>
+          <p:cNvPr id="13" name="Picture 12" descr="b031d4b8beeb8414.png"/>
           <p:cNvPicPr>
             <a:picLocks noChangeAspect="1"/>
           </p:cNvPicPr>
@@ -13092,7 +11686,7 @@
         </p:blipFill>
         <p:spPr>
           <a:xfrm>
-            <a:off x="8426494" y="2462784"/>
+            <a:off x="8426494" y="2142744"/>
             <a:ext cx="271272" cy="277368"/>
           </a:xfrm>
           <a:prstGeom prst="rect">
@@ -13102,13 +11696,13 @@
       </p:pic>
       <p:sp>
         <p:nvSpPr>
-          <p:cNvPr id="15" name="TextBox 14"/>
-          <p:cNvSpPr txBox="1"/>
-          <p:nvPr/>
-        </p:nvSpPr>
-        <p:spPr>
-          <a:xfrm>
-            <a:off x="1874519" y="3177540"/>
+          <p:cNvPr id="14" name="TextBox 13"/>
+          <p:cNvSpPr txBox="1"/>
+          <p:nvPr/>
+        </p:nvSpPr>
+        <p:spPr>
+          <a:xfrm>
+            <a:off x="1874519" y="2857500"/>
             <a:ext cx="3065570" cy="457200"/>
           </a:xfrm>
           <a:prstGeom prst="rect">
@@ -13137,7 +11731,7 @@
       </p:sp>
       <p:pic>
         <p:nvPicPr>
-          <p:cNvPr id="16" name="Picture 15" descr="5fa67493f2d0b1ad.png"/>
+          <p:cNvPr id="15" name="Picture 14" descr="5fa67493f2d0b1ad.png"/>
           <p:cNvPicPr>
             <a:picLocks noChangeAspect="1"/>
           </p:cNvPicPr>
@@ -13151,7 +11745,7 @@
         </p:blipFill>
         <p:spPr>
           <a:xfrm>
-            <a:off x="4802930" y="3268980"/>
+            <a:off x="4802930" y="2948940"/>
             <a:ext cx="265176" cy="274320"/>
           </a:xfrm>
           <a:prstGeom prst="rect">
@@ -13161,13 +11755,13 @@
       </p:pic>
       <p:sp>
         <p:nvSpPr>
-          <p:cNvPr id="17" name="TextBox 16"/>
-          <p:cNvSpPr txBox="1"/>
-          <p:nvPr/>
-        </p:nvSpPr>
-        <p:spPr>
-          <a:xfrm>
-            <a:off x="5068106" y="3177540"/>
+          <p:cNvPr id="16" name="TextBox 15"/>
+          <p:cNvSpPr txBox="1"/>
+          <p:nvPr/>
+        </p:nvSpPr>
+        <p:spPr>
+          <a:xfrm>
+            <a:off x="5068106" y="2857500"/>
             <a:ext cx="674751" cy="457200"/>
           </a:xfrm>
           <a:prstGeom prst="rect">
@@ -13196,7 +11790,7 @@
       </p:sp>
       <p:pic>
         <p:nvPicPr>
-          <p:cNvPr id="18" name="Picture 17" descr="cd79bb74d01bc946.png"/>
+          <p:cNvPr id="17" name="Picture 16" descr="cd79bb74d01bc946.png"/>
           <p:cNvPicPr>
             <a:picLocks noChangeAspect="1"/>
           </p:cNvPicPr>
@@ -13210,7 +11804,7 @@
         </p:blipFill>
         <p:spPr>
           <a:xfrm>
-            <a:off x="5605697" y="3264408"/>
+            <a:off x="5605697" y="2944368"/>
             <a:ext cx="265176" cy="283464"/>
           </a:xfrm>
           <a:prstGeom prst="rect">
@@ -13220,13 +11814,13 @@
       </p:pic>
       <p:sp>
         <p:nvSpPr>
-          <p:cNvPr id="19" name="TextBox 18"/>
-          <p:cNvSpPr txBox="1"/>
-          <p:nvPr/>
-        </p:nvSpPr>
-        <p:spPr>
-          <a:xfrm>
-            <a:off x="5870873" y="3177540"/>
+          <p:cNvPr id="18" name="TextBox 17"/>
+          <p:cNvSpPr txBox="1"/>
+          <p:nvPr/>
+        </p:nvSpPr>
+        <p:spPr>
+          <a:xfrm>
+            <a:off x="5870873" y="2857500"/>
             <a:ext cx="347771" cy="457200"/>
           </a:xfrm>
           <a:prstGeom prst="rect">
@@ -13255,7 +11849,7 @@
       </p:sp>
       <p:pic>
         <p:nvPicPr>
-          <p:cNvPr id="20" name="Picture 19" descr="0663332b63521aed.png"/>
+          <p:cNvPr id="19" name="Picture 18" descr="0663332b63521aed.png"/>
           <p:cNvPicPr>
             <a:picLocks noChangeAspect="1"/>
           </p:cNvPicPr>
@@ -13269,7 +11863,7 @@
         </p:blipFill>
         <p:spPr>
           <a:xfrm>
-            <a:off x="6630125" y="3264408"/>
+            <a:off x="6630125" y="2944368"/>
             <a:ext cx="265176" cy="283464"/>
           </a:xfrm>
           <a:prstGeom prst="rect">
@@ -13279,13 +11873,13 @@
       </p:pic>
       <p:sp>
         <p:nvSpPr>
-          <p:cNvPr id="21" name="TextBox 20"/>
-          <p:cNvSpPr txBox="1"/>
-          <p:nvPr/>
-        </p:nvSpPr>
-        <p:spPr>
-          <a:xfrm>
-            <a:off x="6895301" y="3177540"/>
+          <p:cNvPr id="20" name="TextBox 19"/>
+          <p:cNvSpPr txBox="1"/>
+          <p:nvPr/>
+        </p:nvSpPr>
+        <p:spPr>
+          <a:xfrm>
+            <a:off x="6895301" y="2857500"/>
             <a:ext cx="1616354" cy="457200"/>
           </a:xfrm>
           <a:prstGeom prst="rect">
@@ -13314,13 +11908,13 @@
       </p:sp>
       <p:sp>
         <p:nvSpPr>
-          <p:cNvPr id="22" name="TextBox 21"/>
-          <p:cNvSpPr txBox="1"/>
-          <p:nvPr/>
-        </p:nvSpPr>
-        <p:spPr>
-          <a:xfrm>
-            <a:off x="1874519" y="3863340"/>
+          <p:cNvPr id="21" name="TextBox 20"/>
+          <p:cNvSpPr txBox="1"/>
+          <p:nvPr/>
+        </p:nvSpPr>
+        <p:spPr>
+          <a:xfrm>
+            <a:off x="1874519" y="3543300"/>
             <a:ext cx="4084107" cy="457200"/>
           </a:xfrm>
           <a:prstGeom prst="rect">
@@ -13349,7 +11943,7 @@
       </p:sp>
       <p:pic>
         <p:nvPicPr>
-          <p:cNvPr id="23" name="Picture 22" descr="e5446a4e89f9a3af.png"/>
+          <p:cNvPr id="22" name="Picture 21" descr="e5446a4e89f9a3af.png"/>
           <p:cNvPicPr>
             <a:picLocks noChangeAspect="1"/>
           </p:cNvPicPr>
@@ -13363,7 +11957,7 @@
         </p:blipFill>
         <p:spPr>
           <a:xfrm>
-            <a:off x="5821467" y="3813048"/>
+            <a:off x="5821467" y="3493008"/>
             <a:ext cx="377952" cy="557784"/>
           </a:xfrm>
           <a:prstGeom prst="rect">
@@ -13373,7 +11967,7 @@
       </p:pic>
       <p:pic>
         <p:nvPicPr>
-          <p:cNvPr id="24" name="Picture 23" descr="84c4e18228051985.png"/>
+          <p:cNvPr id="23" name="Picture 22" descr="84c4e18228051985.png"/>
           <p:cNvPicPr>
             <a:picLocks noChangeAspect="1"/>
           </p:cNvPicPr>
@@ -13387,7 +11981,7 @@
         </p:blipFill>
         <p:spPr>
           <a:xfrm>
-            <a:off x="6748059" y="3813048"/>
+            <a:off x="6748059" y="3493008"/>
             <a:ext cx="377952" cy="557784"/>
           </a:xfrm>
           <a:prstGeom prst="rect">
@@ -13518,44 +12112,9 @@
           </a:fontRef>
         </p:style>
       </p:cxnSp>
-      <p:sp>
-        <p:nvSpPr>
-          <p:cNvPr id="5" name="TextBox 4"/>
-          <p:cNvSpPr txBox="1"/>
-          <p:nvPr/>
-        </p:nvSpPr>
-        <p:spPr>
-          <a:xfrm>
-            <a:off x="777240" y="1261872"/>
-            <a:ext cx="10607040" cy="310896"/>
-          </a:xfrm>
-          <a:prstGeom prst="rect">
-            <a:avLst/>
-          </a:prstGeom>
-          <a:noFill/>
-        </p:spPr>
-        <p:txBody>
-          <a:bodyPr wrap="square" lIns="45720" rIns="45720" tIns="18288" bIns="18288" anchor="t">
-            <a:spAutoFit/>
-          </a:bodyPr>
-          <a:lstStyle/>
-          <a:p>
-            <a:pPr algn="l"/>
-            <a:r>
-              <a:rPr sz="1700" b="0" i="1">
-                <a:solidFill>
-                  <a:srgbClr val="6B6B6B"/>
-                </a:solidFill>
-                <a:latin typeface="Century Schoolbook"/>
-              </a:rPr>
-              <a:t>Answer.</a:t>
-            </a:r>
-          </a:p>
-        </p:txBody>
-      </p:sp>
       <p:cxnSp>
         <p:nvCxnSpPr>
-          <p:cNvPr id="6" name="Connector 5"/>
+          <p:cNvPr id="5" name="Connector 4"/>
           <p:cNvCxnSpPr/>
           <p:nvPr/>
         </p:nvCxnSpPr>
@@ -13590,7 +12149,7 @@
       </p:cxnSp>
       <p:sp>
         <p:nvSpPr>
-          <p:cNvPr id="7" name="TextBox 6"/>
+          <p:cNvPr id="6" name="TextBox 5"/>
           <p:cNvSpPr txBox="1"/>
           <p:nvPr/>
         </p:nvSpPr>
@@ -13625,7 +12184,7 @@
       </p:sp>
       <p:sp>
         <p:nvSpPr>
-          <p:cNvPr id="8" name="TextBox 7"/>
+          <p:cNvPr id="7" name="TextBox 6"/>
           <p:cNvSpPr txBox="1"/>
           <p:nvPr/>
         </p:nvSpPr>
@@ -13660,7 +12219,7 @@
       </p:sp>
       <p:pic>
         <p:nvPicPr>
-          <p:cNvPr id="9" name="Picture 8" descr="7d2314fb4fc5114f.png"/>
+          <p:cNvPr id="8" name="Picture 7" descr="7d2314fb4fc5114f.png"/>
           <p:cNvPicPr>
             <a:picLocks noChangeAspect="1"/>
           </p:cNvPicPr>
@@ -13684,60 +12243,7 @@
       </p:pic>
       <p:sp>
         <p:nvSpPr>
-          <p:cNvPr id="10" name="TextBox 9"/>
-          <p:cNvSpPr txBox="1"/>
-          <p:nvPr/>
-        </p:nvSpPr>
-        <p:spPr>
-          <a:xfrm>
-            <a:off x="1828800" y="3236975"/>
-            <a:ext cx="8503920" cy="548640"/>
-          </a:xfrm>
-          <a:prstGeom prst="rect">
-            <a:avLst/>
-          </a:prstGeom>
-          <a:noFill/>
-        </p:spPr>
-        <p:txBody>
-          <a:bodyPr wrap="square" lIns="45720" rIns="45720" tIns="18288" bIns="18288" anchor="t">
-            <a:spAutoFit/>
-          </a:bodyPr>
-          <a:lstStyle/>
-          <a:p>
-            <a:pPr algn="ctr"/>
-            <a:r>
-              <a:rPr sz="2400" b="0" i="0">
-                <a:solidFill>
-                  <a:srgbClr val="6B6B6B"/>
-                </a:solidFill>
-                <a:latin typeface="Century Schoolbook"/>
-              </a:rPr>
-              <a:t>(2/3)</a:t>
-            </a:r>
-            <a:r>
-              <a:rPr sz="2400" b="0" i="0" baseline="30000">
-                <a:solidFill>
-                  <a:srgbClr val="6B6B6B"/>
-                </a:solidFill>
-                <a:latin typeface="Century Schoolbook"/>
-              </a:rPr>
-              <a:t>3</a:t>
-            </a:r>
-            <a:r>
-              <a:rPr sz="2400" b="0" i="0">
-                <a:solidFill>
-                  <a:srgbClr val="6B6B6B"/>
-                </a:solidFill>
-                <a:latin typeface="Century Schoolbook"/>
-              </a:rPr>
-              <a:t> inside, then power of a power</a:t>
-            </a:r>
-          </a:p>
-        </p:txBody>
-      </p:sp>
-      <p:sp>
-        <p:nvSpPr>
-          <p:cNvPr id="11" name="TextBox 10"/>
+          <p:cNvPr id="9" name="TextBox 8"/>
           <p:cNvSpPr txBox="1"/>
           <p:nvPr/>
         </p:nvSpPr>
@@ -13772,7 +12278,7 @@
       </p:sp>
       <p:pic>
         <p:nvPicPr>
-          <p:cNvPr id="12" name="Picture 11" descr="2e17728107926c07.png"/>
+          <p:cNvPr id="10" name="Picture 9" descr="2e17728107926c07.png"/>
           <p:cNvPicPr>
             <a:picLocks noChangeAspect="1"/>
           </p:cNvPicPr>
@@ -13917,44 +12423,9 @@
           </a:fontRef>
         </p:style>
       </p:cxnSp>
-      <p:sp>
-        <p:nvSpPr>
-          <p:cNvPr id="5" name="TextBox 4"/>
-          <p:cNvSpPr txBox="1"/>
-          <p:nvPr/>
-        </p:nvSpPr>
-        <p:spPr>
-          <a:xfrm>
-            <a:off x="777240" y="1261872"/>
-            <a:ext cx="10607040" cy="310896"/>
-          </a:xfrm>
-          <a:prstGeom prst="rect">
-            <a:avLst/>
-          </a:prstGeom>
-          <a:noFill/>
-        </p:spPr>
-        <p:txBody>
-          <a:bodyPr wrap="square" lIns="45720" rIns="45720" tIns="18288" bIns="18288" anchor="t">
-            <a:spAutoFit/>
-          </a:bodyPr>
-          <a:lstStyle/>
-          <a:p>
-            <a:pPr algn="l"/>
-            <a:r>
-              <a:rPr sz="1700" b="0" i="1">
-                <a:solidFill>
-                  <a:srgbClr val="6B6B6B"/>
-                </a:solidFill>
-                <a:latin typeface="Century Schoolbook"/>
-              </a:rPr>
-              <a:t>Take your time. Boards up when you have written it.</a:t>
-            </a:r>
-          </a:p>
-        </p:txBody>
-      </p:sp>
       <p:cxnSp>
         <p:nvCxnSpPr>
-          <p:cNvPr id="6" name="Connector 5"/>
+          <p:cNvPr id="5" name="Connector 4"/>
           <p:cNvCxnSpPr/>
           <p:nvPr/>
         </p:nvCxnSpPr>
@@ -13989,7 +12460,7 @@
       </p:cxnSp>
       <p:sp>
         <p:nvSpPr>
-          <p:cNvPr id="7" name="TextBox 6"/>
+          <p:cNvPr id="6" name="TextBox 5"/>
           <p:cNvSpPr txBox="1"/>
           <p:nvPr/>
         </p:nvSpPr>
@@ -14024,7 +12495,7 @@
       </p:sp>
       <p:sp>
         <p:nvSpPr>
-          <p:cNvPr id="8" name="TextBox 7"/>
+          <p:cNvPr id="7" name="TextBox 6"/>
           <p:cNvSpPr txBox="1"/>
           <p:nvPr/>
         </p:nvSpPr>
@@ -14059,7 +12530,7 @@
       </p:sp>
       <p:sp>
         <p:nvSpPr>
-          <p:cNvPr id="9" name="TextBox 8"/>
+          <p:cNvPr id="8" name="TextBox 7"/>
           <p:cNvSpPr txBox="1"/>
           <p:nvPr/>
         </p:nvSpPr>
@@ -14094,7 +12565,7 @@
       </p:sp>
       <p:pic>
         <p:nvPicPr>
-          <p:cNvPr id="10" name="Picture 9" descr="bcbcbf803cfe7ecd.png"/>
+          <p:cNvPr id="9" name="Picture 8" descr="bcbcbf803cfe7ecd.png"/>
           <p:cNvPicPr>
             <a:picLocks noChangeAspect="1"/>
           </p:cNvPicPr>
@@ -14118,7 +12589,7 @@
       </p:pic>
       <p:sp>
         <p:nvSpPr>
-          <p:cNvPr id="11" name="TextBox 10"/>
+          <p:cNvPr id="10" name="TextBox 9"/>
           <p:cNvSpPr txBox="1"/>
           <p:nvPr/>
         </p:nvSpPr>
@@ -14153,7 +12624,7 @@
       </p:sp>
       <p:pic>
         <p:nvPicPr>
-          <p:cNvPr id="12" name="Picture 11" descr="9b43b28c9551277e.png"/>
+          <p:cNvPr id="11" name="Picture 10" descr="9b43b28c9551277e.png"/>
           <p:cNvPicPr>
             <a:picLocks noChangeAspect="1"/>
           </p:cNvPicPr>
@@ -14177,7 +12648,7 @@
       </p:pic>
       <p:sp>
         <p:nvSpPr>
-          <p:cNvPr id="13" name="TextBox 12"/>
+          <p:cNvPr id="12" name="TextBox 11"/>
           <p:cNvSpPr txBox="1"/>
           <p:nvPr/>
         </p:nvSpPr>
@@ -14212,7 +12683,7 @@
       </p:sp>
       <p:sp>
         <p:nvSpPr>
-          <p:cNvPr id="14" name="TextBox 13"/>
+          <p:cNvPr id="13" name="TextBox 12"/>
           <p:cNvSpPr txBox="1"/>
           <p:nvPr/>
         </p:nvSpPr>
@@ -14241,41 +12712,6 @@
                 <a:latin typeface="Century Schoolbook"/>
               </a:rPr>
               <a:t>Write your answer in sentences.</a:t>
-            </a:r>
-          </a:p>
-        </p:txBody>
-      </p:sp>
-      <p:sp>
-        <p:nvSpPr>
-          <p:cNvPr id="15" name="TextBox 14"/>
-          <p:cNvSpPr txBox="1"/>
-          <p:nvPr/>
-        </p:nvSpPr>
-        <p:spPr>
-          <a:xfrm>
-            <a:off x="777240" y="4828032"/>
-            <a:ext cx="10607040" cy="365760"/>
-          </a:xfrm>
-          <a:prstGeom prst="rect">
-            <a:avLst/>
-          </a:prstGeom>
-          <a:noFill/>
-        </p:spPr>
-        <p:txBody>
-          <a:bodyPr wrap="square" lIns="45720" rIns="45720" tIns="18288" bIns="18288" anchor="t">
-            <a:spAutoFit/>
-          </a:bodyPr>
-          <a:lstStyle/>
-          <a:p>
-            <a:pPr algn="ctr"/>
-            <a:r>
-              <a:rPr sz="1900" b="0" i="1">
-                <a:solidFill>
-                  <a:srgbClr val="6B6B6B"/>
-                </a:solidFill>
-                <a:latin typeface="Century Schoolbook"/>
-              </a:rPr>
-              <a:t>Say what the negative exponent does, and what it does not do. Give the correct rewrite.</a:t>
             </a:r>
           </a:p>
         </p:txBody>
@@ -14403,44 +12839,9 @@
           </a:fontRef>
         </p:style>
       </p:cxnSp>
-      <p:sp>
-        <p:nvSpPr>
-          <p:cNvPr id="5" name="TextBox 4"/>
-          <p:cNvSpPr txBox="1"/>
-          <p:nvPr/>
-        </p:nvSpPr>
-        <p:spPr>
-          <a:xfrm>
-            <a:off x="777240" y="1261872"/>
-            <a:ext cx="10607040" cy="310896"/>
-          </a:xfrm>
-          <a:prstGeom prst="rect">
-            <a:avLst/>
-          </a:prstGeom>
-          <a:noFill/>
-        </p:spPr>
-        <p:txBody>
-          <a:bodyPr wrap="square" lIns="45720" rIns="45720" tIns="18288" bIns="18288" anchor="t">
-            <a:spAutoFit/>
-          </a:bodyPr>
-          <a:lstStyle/>
-          <a:p>
-            <a:pPr algn="l"/>
-            <a:r>
-              <a:rPr sz="1700" b="0" i="1">
-                <a:solidFill>
-                  <a:srgbClr val="6B6B6B"/>
-                </a:solidFill>
-                <a:latin typeface="Century Schoolbook"/>
-              </a:rPr>
-              <a:t>Answer.</a:t>
-            </a:r>
-          </a:p>
-        </p:txBody>
-      </p:sp>
       <p:cxnSp>
         <p:nvCxnSpPr>
-          <p:cNvPr id="6" name="Connector 5"/>
+          <p:cNvPr id="5" name="Connector 4"/>
           <p:cNvCxnSpPr/>
           <p:nvPr/>
         </p:nvCxnSpPr>
@@ -14475,7 +12876,7 @@
       </p:cxnSp>
       <p:sp>
         <p:nvSpPr>
-          <p:cNvPr id="7" name="TextBox 6"/>
+          <p:cNvPr id="6" name="TextBox 5"/>
           <p:cNvSpPr txBox="1"/>
           <p:nvPr/>
         </p:nvSpPr>
@@ -14510,7 +12911,7 @@
       </p:sp>
       <p:sp>
         <p:nvSpPr>
-          <p:cNvPr id="8" name="TextBox 7"/>
+          <p:cNvPr id="7" name="TextBox 6"/>
           <p:cNvSpPr txBox="1"/>
           <p:nvPr/>
         </p:nvSpPr>
@@ -14545,7 +12946,7 @@
       </p:sp>
       <p:sp>
         <p:nvSpPr>
-          <p:cNvPr id="9" name="TextBox 8"/>
+          <p:cNvPr id="8" name="TextBox 7"/>
           <p:cNvSpPr txBox="1"/>
           <p:nvPr/>
         </p:nvSpPr>
@@ -14580,7 +12981,7 @@
       </p:sp>
       <p:pic>
         <p:nvPicPr>
-          <p:cNvPr id="10" name="Picture 9" descr="61e0767165f6b191.png"/>
+          <p:cNvPr id="9" name="Picture 8" descr="61e0767165f6b191.png"/>
           <p:cNvPicPr>
             <a:picLocks noChangeAspect="1"/>
           </p:cNvPicPr>
@@ -14604,7 +13005,7 @@
       </p:pic>
       <p:sp>
         <p:nvSpPr>
-          <p:cNvPr id="11" name="TextBox 10"/>
+          <p:cNvPr id="10" name="TextBox 9"/>
           <p:cNvSpPr txBox="1"/>
           <p:nvPr/>
         </p:nvSpPr>
@@ -14639,7 +13040,7 @@
       </p:sp>
       <p:pic>
         <p:nvPicPr>
-          <p:cNvPr id="12" name="Picture 11" descr="5c0a9d4ef3b8e54c.png"/>
+          <p:cNvPr id="11" name="Picture 10" descr="5c0a9d4ef3b8e54c.png"/>
           <p:cNvPicPr>
             <a:picLocks noChangeAspect="1"/>
           </p:cNvPicPr>
@@ -14663,7 +13064,7 @@
       </p:pic>
       <p:sp>
         <p:nvSpPr>
-          <p:cNvPr id="13" name="TextBox 12"/>
+          <p:cNvPr id="12" name="TextBox 11"/>
           <p:cNvSpPr txBox="1"/>
           <p:nvPr/>
         </p:nvSpPr>
@@ -14698,42 +13099,7 @@
       </p:sp>
       <p:sp>
         <p:nvSpPr>
-          <p:cNvPr id="14" name="TextBox 13"/>
-          <p:cNvSpPr txBox="1"/>
-          <p:nvPr/>
-        </p:nvSpPr>
-        <p:spPr>
-          <a:xfrm>
-            <a:off x="1828800" y="3680791"/>
-            <a:ext cx="8503920" cy="548640"/>
-          </a:xfrm>
-          <a:prstGeom prst="rect">
-            <a:avLst/>
-          </a:prstGeom>
-          <a:noFill/>
-        </p:spPr>
-        <p:txBody>
-          <a:bodyPr wrap="square" lIns="45720" rIns="45720" tIns="18288" bIns="18288" anchor="t">
-            <a:spAutoFit/>
-          </a:bodyPr>
-          <a:lstStyle/>
-          <a:p>
-            <a:pPr algn="ctr"/>
-            <a:r>
-              <a:rPr sz="2400" b="0" i="0">
-                <a:solidFill>
-                  <a:srgbClr val="6B6B6B"/>
-                </a:solidFill>
-                <a:latin typeface="Century Schoolbook"/>
-              </a:rPr>
-              <a:t>the exponent flips the fraction; it never touches the sign</a:t>
-            </a:r>
-          </a:p>
-        </p:txBody>
-      </p:sp>
-      <p:sp>
-        <p:nvSpPr>
-          <p:cNvPr id="15" name="TextBox 14"/>
+          <p:cNvPr id="13" name="TextBox 12"/>
           <p:cNvSpPr txBox="1"/>
           <p:nvPr/>
         </p:nvSpPr>
@@ -14916,44 +13282,9 @@
           </a:fontRef>
         </p:style>
       </p:cxnSp>
-      <p:sp>
-        <p:nvSpPr>
-          <p:cNvPr id="5" name="TextBox 4"/>
-          <p:cNvSpPr txBox="1"/>
-          <p:nvPr/>
-        </p:nvSpPr>
-        <p:spPr>
-          <a:xfrm>
-            <a:off x="777240" y="1261872"/>
-            <a:ext cx="10607040" cy="310896"/>
-          </a:xfrm>
-          <a:prstGeom prst="rect">
-            <a:avLst/>
-          </a:prstGeom>
-          <a:noFill/>
-        </p:spPr>
-        <p:txBody>
-          <a:bodyPr wrap="square" lIns="45720" rIns="45720" tIns="18288" bIns="18288" anchor="t">
-            <a:spAutoFit/>
-          </a:bodyPr>
-          <a:lstStyle/>
-          <a:p>
-            <a:pPr algn="l"/>
-            <a:r>
-              <a:rPr sz="1700" b="0" i="1">
-                <a:solidFill>
-                  <a:srgbClr val="6B6B6B"/>
-                </a:solidFill>
-                <a:latin typeface="Century Schoolbook"/>
-              </a:rPr>
-              <a:t>Six questions. On your own, in silence.</a:t>
-            </a:r>
-          </a:p>
-        </p:txBody>
-      </p:sp>
       <p:cxnSp>
         <p:nvCxnSpPr>
-          <p:cNvPr id="6" name="Connector 5"/>
+          <p:cNvPr id="5" name="Connector 4"/>
           <p:cNvCxnSpPr/>
           <p:nvPr/>
         </p:nvCxnSpPr>
@@ -14988,7 +13319,7 @@
       </p:cxnSp>
       <p:sp>
         <p:nvSpPr>
-          <p:cNvPr id="7" name="TextBox 6"/>
+          <p:cNvPr id="6" name="TextBox 5"/>
           <p:cNvSpPr txBox="1"/>
           <p:nvPr/>
         </p:nvSpPr>
@@ -15023,7 +13354,7 @@
       </p:sp>
       <p:sp>
         <p:nvSpPr>
-          <p:cNvPr id="8" name="TextBox 7"/>
+          <p:cNvPr id="7" name="TextBox 6"/>
           <p:cNvSpPr txBox="1"/>
           <p:nvPr/>
         </p:nvSpPr>
@@ -15058,7 +13389,7 @@
       </p:sp>
       <p:sp>
         <p:nvSpPr>
-          <p:cNvPr id="9" name="TextBox 8"/>
+          <p:cNvPr id="8" name="TextBox 7"/>
           <p:cNvSpPr txBox="1"/>
           <p:nvPr/>
         </p:nvSpPr>
@@ -15093,7 +13424,7 @@
       </p:sp>
       <p:sp>
         <p:nvSpPr>
-          <p:cNvPr id="10" name="TextBox 9"/>
+          <p:cNvPr id="9" name="TextBox 8"/>
           <p:cNvSpPr txBox="1"/>
           <p:nvPr/>
         </p:nvSpPr>
@@ -15128,7 +13459,7 @@
       </p:sp>
       <p:sp>
         <p:nvSpPr>
-          <p:cNvPr id="11" name="TextBox 10"/>
+          <p:cNvPr id="10" name="TextBox 9"/>
           <p:cNvSpPr txBox="1"/>
           <p:nvPr/>
         </p:nvSpPr>
@@ -15163,7 +13494,7 @@
       </p:sp>
       <p:sp>
         <p:nvSpPr>
-          <p:cNvPr id="12" name="TextBox 11"/>
+          <p:cNvPr id="11" name="TextBox 10"/>
           <p:cNvSpPr txBox="1"/>
           <p:nvPr/>
         </p:nvSpPr>
@@ -15198,7 +13529,7 @@
       </p:sp>
       <p:sp>
         <p:nvSpPr>
-          <p:cNvPr id="13" name="TextBox 12"/>
+          <p:cNvPr id="12" name="TextBox 11"/>
           <p:cNvSpPr txBox="1"/>
           <p:nvPr/>
         </p:nvSpPr>
@@ -15233,7 +13564,7 @@
       </p:sp>
       <p:sp>
         <p:nvSpPr>
-          <p:cNvPr id="14" name="TextBox 13"/>
+          <p:cNvPr id="13" name="TextBox 12"/>
           <p:cNvSpPr txBox="1"/>
           <p:nvPr/>
         </p:nvSpPr>
@@ -15389,44 +13720,9 @@
           </a:fontRef>
         </p:style>
       </p:cxnSp>
-      <p:sp>
-        <p:nvSpPr>
-          <p:cNvPr id="5" name="TextBox 4"/>
-          <p:cNvSpPr txBox="1"/>
-          <p:nvPr/>
-        </p:nvSpPr>
-        <p:spPr>
-          <a:xfrm>
-            <a:off x="777240" y="1261872"/>
-            <a:ext cx="10607040" cy="310896"/>
-          </a:xfrm>
-          <a:prstGeom prst="rect">
-            <a:avLst/>
-          </a:prstGeom>
-          <a:noFill/>
-        </p:spPr>
-        <p:txBody>
-          <a:bodyPr wrap="square" lIns="45720" rIns="45720" tIns="18288" bIns="18288" anchor="t">
-            <a:spAutoFit/>
-          </a:bodyPr>
-          <a:lstStyle/>
-          <a:p>
-            <a:pPr algn="l"/>
-            <a:r>
-              <a:rPr sz="1700" b="0" i="1">
-                <a:solidFill>
-                  <a:srgbClr val="6B6B6B"/>
-                </a:solidFill>
-                <a:latin typeface="Century Schoolbook"/>
-              </a:rPr>
-              <a:t>Last five minutes.</a:t>
-            </a:r>
-          </a:p>
-        </p:txBody>
-      </p:sp>
       <p:cxnSp>
         <p:nvCxnSpPr>
-          <p:cNvPr id="6" name="Connector 5"/>
+          <p:cNvPr id="5" name="Connector 4"/>
           <p:cNvCxnSpPr/>
           <p:nvPr/>
         </p:nvCxnSpPr>
@@ -15461,7 +13757,7 @@
       </p:cxnSp>
       <p:sp>
         <p:nvSpPr>
-          <p:cNvPr id="7" name="TextBox 6"/>
+          <p:cNvPr id="6" name="TextBox 5"/>
           <p:cNvSpPr txBox="1"/>
           <p:nvPr/>
         </p:nvSpPr>
@@ -15496,7 +13792,7 @@
       </p:sp>
       <p:sp>
         <p:nvSpPr>
-          <p:cNvPr id="8" name="TextBox 7"/>
+          <p:cNvPr id="7" name="TextBox 6"/>
           <p:cNvSpPr txBox="1"/>
           <p:nvPr/>
         </p:nvSpPr>
@@ -15531,7 +13827,7 @@
       </p:sp>
       <p:sp>
         <p:nvSpPr>
-          <p:cNvPr id="9" name="TextBox 8"/>
+          <p:cNvPr id="8" name="TextBox 7"/>
           <p:cNvSpPr txBox="1"/>
           <p:nvPr/>
         </p:nvSpPr>
@@ -15566,7 +13862,7 @@
       </p:sp>
       <p:sp>
         <p:nvSpPr>
-          <p:cNvPr id="10" name="TextBox 9"/>
+          <p:cNvPr id="9" name="TextBox 8"/>
           <p:cNvSpPr txBox="1"/>
           <p:nvPr/>
         </p:nvSpPr>
@@ -15601,7 +13897,7 @@
       </p:sp>
       <p:sp>
         <p:nvSpPr>
-          <p:cNvPr id="11" name="TextBox 10"/>
+          <p:cNvPr id="10" name="TextBox 9"/>
           <p:cNvSpPr txBox="1"/>
           <p:nvPr/>
         </p:nvSpPr>
@@ -15636,7 +13932,7 @@
       </p:sp>
       <p:sp>
         <p:nvSpPr>
-          <p:cNvPr id="12" name="TextBox 11"/>
+          <p:cNvPr id="11" name="TextBox 10"/>
           <p:cNvSpPr txBox="1"/>
           <p:nvPr/>
         </p:nvSpPr>
@@ -15671,7 +13967,7 @@
       </p:sp>
       <p:sp>
         <p:nvSpPr>
-          <p:cNvPr id="13" name="TextBox 12"/>
+          <p:cNvPr id="12" name="TextBox 11"/>
           <p:cNvSpPr txBox="1"/>
           <p:nvPr/>
         </p:nvSpPr>
@@ -15706,7 +14002,7 @@
       </p:sp>
       <p:sp>
         <p:nvSpPr>
-          <p:cNvPr id="14" name="TextBox 13"/>
+          <p:cNvPr id="13" name="TextBox 12"/>
           <p:cNvSpPr txBox="1"/>
           <p:nvPr/>
         </p:nvSpPr>
@@ -15741,7 +14037,7 @@
       </p:sp>
       <p:sp>
         <p:nvSpPr>
-          <p:cNvPr id="15" name="TextBox 14"/>
+          <p:cNvPr id="14" name="TextBox 13"/>
           <p:cNvSpPr txBox="1"/>
           <p:nvPr/>
         </p:nvSpPr>
@@ -15776,7 +14072,7 @@
       </p:sp>
       <p:sp>
         <p:nvSpPr>
-          <p:cNvPr id="16" name="TextBox 15"/>
+          <p:cNvPr id="15" name="TextBox 14"/>
           <p:cNvSpPr txBox="1"/>
           <p:nvPr/>
         </p:nvSpPr>
@@ -15932,44 +14228,9 @@
           </a:fontRef>
         </p:style>
       </p:cxnSp>
-      <p:sp>
-        <p:nvSpPr>
-          <p:cNvPr id="5" name="TextBox 4"/>
-          <p:cNvSpPr txBox="1"/>
-          <p:nvPr/>
-        </p:nvSpPr>
-        <p:spPr>
-          <a:xfrm>
-            <a:off x="777240" y="1261872"/>
-            <a:ext cx="10607040" cy="310896"/>
-          </a:xfrm>
-          <a:prstGeom prst="rect">
-            <a:avLst/>
-          </a:prstGeom>
-          <a:noFill/>
-        </p:spPr>
-        <p:txBody>
-          <a:bodyPr wrap="square" lIns="45720" rIns="45720" tIns="18288" bIns="18288" anchor="t">
-            <a:spAutoFit/>
-          </a:bodyPr>
-          <a:lstStyle/>
-          <a:p>
-            <a:pPr algn="l"/>
-            <a:r>
-              <a:rPr sz="1700" b="0" i="1">
-                <a:solidFill>
-                  <a:srgbClr val="6B6B6B"/>
-                </a:solidFill>
-                <a:latin typeface="Century Schoolbook"/>
-              </a:rPr>
-              <a:t>Copy the table.</a:t>
-            </a:r>
-          </a:p>
-        </p:txBody>
-      </p:sp>
       <p:cxnSp>
         <p:nvCxnSpPr>
-          <p:cNvPr id="6" name="Connector 5"/>
+          <p:cNvPr id="5" name="Connector 4"/>
           <p:cNvCxnSpPr/>
           <p:nvPr/>
         </p:nvCxnSpPr>
@@ -16004,7 +14265,7 @@
       </p:cxnSp>
       <p:sp>
         <p:nvSpPr>
-          <p:cNvPr id="7" name="TextBox 6"/>
+          <p:cNvPr id="6" name="TextBox 5"/>
           <p:cNvSpPr txBox="1"/>
           <p:nvPr/>
         </p:nvSpPr>
@@ -16039,7 +14300,7 @@
       </p:sp>
       <p:sp>
         <p:nvSpPr>
-          <p:cNvPr id="8" name="TextBox 7"/>
+          <p:cNvPr id="7" name="TextBox 6"/>
           <p:cNvSpPr txBox="1"/>
           <p:nvPr/>
         </p:nvSpPr>
@@ -16074,13 +14335,13 @@
       </p:sp>
       <p:sp>
         <p:nvSpPr>
-          <p:cNvPr id="9" name="TextBox 8"/>
-          <p:cNvSpPr txBox="1"/>
-          <p:nvPr/>
-        </p:nvSpPr>
-        <p:spPr>
-          <a:xfrm>
-            <a:off x="777240" y="1737360"/>
+          <p:cNvPr id="8" name="TextBox 7"/>
+          <p:cNvSpPr txBox="1"/>
+          <p:nvPr/>
+        </p:nvSpPr>
+        <p:spPr>
+          <a:xfrm>
+            <a:off x="777240" y="1389888"/>
             <a:ext cx="10607040" cy="402336"/>
           </a:xfrm>
           <a:prstGeom prst="rect">
@@ -16109,13 +14370,13 @@
       </p:sp>
       <p:cxnSp>
         <p:nvCxnSpPr>
-          <p:cNvPr id="10" name="Connector 9"/>
+          <p:cNvPr id="9" name="Connector 8"/>
           <p:cNvCxnSpPr/>
           <p:nvPr/>
         </p:nvCxnSpPr>
         <p:spPr>
           <a:xfrm>
-            <a:off x="777240" y="2176272"/>
+            <a:off x="777240" y="1828800"/>
             <a:ext cx="10607040" cy="0"/>
           </a:xfrm>
           <a:prstGeom prst="line">
@@ -16144,14 +14405,14 @@
       </p:cxnSp>
       <p:graphicFrame>
         <p:nvGraphicFramePr>
-          <p:cNvPr id="11" name="Table 10"/>
+          <p:cNvPr id="10" name="Table 9"/>
           <p:cNvGraphicFramePr>
             <a:graphicFrameLocks noGrp="1"/>
           </p:cNvGraphicFramePr>
           <p:nvPr/>
         </p:nvGraphicFramePr>
         <p:xfrm>
-          <a:off x="2651760" y="2340864"/>
+          <a:off x="2651760" y="1993392"/>
           <a:ext cx="6858000" cy="2304288"/>
         </p:xfrm>
         <a:graphic>
@@ -17308,7 +15569,7 @@
         </p:nvSpPr>
         <p:spPr>
           <a:xfrm>
-            <a:off x="777240" y="1737360"/>
+            <a:off x="777240" y="1389888"/>
             <a:ext cx="10607040" cy="402336"/>
           </a:xfrm>
           <a:prstGeom prst="rect">
@@ -17343,7 +15604,7 @@
         </p:nvCxnSpPr>
         <p:spPr>
           <a:xfrm>
-            <a:off x="777240" y="2176272"/>
+            <a:off x="777240" y="1828800"/>
             <a:ext cx="10607040" cy="0"/>
           </a:xfrm>
           <a:prstGeom prst="line">
@@ -17386,7 +15647,7 @@
         </p:blipFill>
         <p:spPr>
           <a:xfrm>
-            <a:off x="3761785" y="2340864"/>
+            <a:off x="3761785" y="1993392"/>
             <a:ext cx="2133600" cy="691896"/>
           </a:xfrm>
           <a:prstGeom prst="rect">
@@ -17402,7 +15663,7 @@
         </p:nvSpPr>
         <p:spPr>
           <a:xfrm>
-            <a:off x="5895385" y="2458212"/>
+            <a:off x="5895385" y="2110740"/>
             <a:ext cx="1299682" cy="457200"/>
           </a:xfrm>
           <a:prstGeom prst="rect">
@@ -17445,7 +15706,7 @@
         </p:blipFill>
         <p:spPr>
           <a:xfrm>
-            <a:off x="7057907" y="2516124"/>
+            <a:off x="7057907" y="2168652"/>
             <a:ext cx="1152144" cy="341376"/>
           </a:xfrm>
           <a:prstGeom prst="rect">
@@ -17461,7 +15722,7 @@
         </p:nvSpPr>
         <p:spPr>
           <a:xfrm>
-            <a:off x="8210051" y="2458212"/>
+            <a:off x="8210051" y="2110740"/>
             <a:ext cx="326842" cy="457200"/>
           </a:xfrm>
           <a:prstGeom prst="rect">
@@ -17504,7 +15765,7 @@
         </p:blipFill>
         <p:spPr>
           <a:xfrm>
-            <a:off x="2625588" y="3307080"/>
+            <a:off x="2625588" y="2959608"/>
             <a:ext cx="3075432" cy="697992"/>
           </a:xfrm>
           <a:prstGeom prst="rect">
@@ -17520,7 +15781,7 @@
         </p:nvSpPr>
         <p:spPr>
           <a:xfrm>
-            <a:off x="5701020" y="3427476"/>
+            <a:off x="5701020" y="3080004"/>
             <a:ext cx="1183151" cy="457200"/>
           </a:xfrm>
           <a:prstGeom prst="rect">
@@ -17563,7 +15824,7 @@
         </p:blipFill>
         <p:spPr>
           <a:xfrm>
-            <a:off x="6747011" y="3311652"/>
+            <a:off x="6747011" y="2964180"/>
             <a:ext cx="2788920" cy="688848"/>
           </a:xfrm>
           <a:prstGeom prst="rect">
@@ -17579,7 +15840,7 @@
         </p:nvSpPr>
         <p:spPr>
           <a:xfrm>
-            <a:off x="987552" y="4343400"/>
+            <a:off x="987552" y="3995928"/>
             <a:ext cx="10131551" cy="475488"/>
           </a:xfrm>
           <a:prstGeom prst="rect">
@@ -17614,7 +15875,7 @@
         </p:nvSpPr>
         <p:spPr>
           <a:xfrm>
-            <a:off x="987552" y="5166359"/>
+            <a:off x="987552" y="4818888"/>
             <a:ext cx="5545365" cy="457200"/>
           </a:xfrm>
           <a:prstGeom prst="rect">
@@ -17657,7 +15918,7 @@
         </p:blipFill>
         <p:spPr>
           <a:xfrm>
-            <a:off x="6395757" y="5056631"/>
+            <a:off x="6395757" y="4709159"/>
             <a:ext cx="3230880" cy="676656"/>
           </a:xfrm>
           <a:prstGeom prst="rect">
@@ -17901,7 +16162,7 @@
         </p:nvSpPr>
         <p:spPr>
           <a:xfrm>
-            <a:off x="777240" y="1737360"/>
+            <a:off x="777240" y="1389888"/>
             <a:ext cx="10607040" cy="402336"/>
           </a:xfrm>
           <a:prstGeom prst="rect">
@@ -17936,7 +16197,7 @@
         </p:nvCxnSpPr>
         <p:spPr>
           <a:xfrm>
-            <a:off x="777240" y="2176272"/>
+            <a:off x="777240" y="1828800"/>
             <a:ext cx="10607040" cy="0"/>
           </a:xfrm>
           <a:prstGeom prst="line">
@@ -17979,7 +16240,7 @@
         </p:blipFill>
         <p:spPr>
           <a:xfrm>
-            <a:off x="2074163" y="2340864"/>
+            <a:off x="2074163" y="1993392"/>
             <a:ext cx="8013192" cy="816864"/>
           </a:xfrm>
           <a:prstGeom prst="rect">
@@ -17995,7 +16256,7 @@
         </p:nvSpPr>
         <p:spPr>
           <a:xfrm>
-            <a:off x="987552" y="3496055"/>
+            <a:off x="987552" y="3148583"/>
             <a:ext cx="10131551" cy="475488"/>
           </a:xfrm>
           <a:prstGeom prst="rect">
@@ -18145,44 +16406,9 @@
           </a:fontRef>
         </p:style>
       </p:cxnSp>
-      <p:sp>
-        <p:nvSpPr>
-          <p:cNvPr id="5" name="TextBox 4"/>
-          <p:cNvSpPr txBox="1"/>
-          <p:nvPr/>
-        </p:nvSpPr>
-        <p:spPr>
-          <a:xfrm>
-            <a:off x="777240" y="1261872"/>
-            <a:ext cx="10607040" cy="310896"/>
-          </a:xfrm>
-          <a:prstGeom prst="rect">
-            <a:avLst/>
-          </a:prstGeom>
-          <a:noFill/>
-        </p:spPr>
-        <p:txBody>
-          <a:bodyPr wrap="square" lIns="45720" rIns="45720" tIns="18288" bIns="18288" anchor="t">
-            <a:spAutoFit/>
-          </a:bodyPr>
-          <a:lstStyle/>
-          <a:p>
-            <a:pPr algn="l"/>
-            <a:r>
-              <a:rPr sz="1700" b="0" i="1">
-                <a:solidFill>
-                  <a:srgbClr val="6B6B6B"/>
-                </a:solidFill>
-                <a:latin typeface="Century Schoolbook"/>
-              </a:rPr>
-              <a:t>Flip, then evaluate.</a:t>
-            </a:r>
-          </a:p>
-        </p:txBody>
-      </p:sp>
       <p:cxnSp>
         <p:nvCxnSpPr>
-          <p:cNvPr id="6" name="Connector 5"/>
+          <p:cNvPr id="5" name="Connector 4"/>
           <p:cNvCxnSpPr/>
           <p:nvPr/>
         </p:nvCxnSpPr>
@@ -18217,7 +16443,7 @@
       </p:cxnSp>
       <p:sp>
         <p:nvSpPr>
-          <p:cNvPr id="7" name="TextBox 6"/>
+          <p:cNvPr id="6" name="TextBox 5"/>
           <p:cNvSpPr txBox="1"/>
           <p:nvPr/>
         </p:nvSpPr>
@@ -18252,7 +16478,7 @@
       </p:sp>
       <p:sp>
         <p:nvSpPr>
-          <p:cNvPr id="8" name="TextBox 7"/>
+          <p:cNvPr id="7" name="TextBox 6"/>
           <p:cNvSpPr txBox="1"/>
           <p:nvPr/>
         </p:nvSpPr>
@@ -18287,7 +16513,7 @@
       </p:sp>
       <p:pic>
         <p:nvPicPr>
-          <p:cNvPr id="9" name="Picture 8" descr="9ed1bed15013a3f1.png"/>
+          <p:cNvPr id="8" name="Picture 7" descr="9ed1bed15013a3f1.png"/>
           <p:cNvPicPr>
             <a:picLocks noChangeAspect="1"/>
           </p:cNvPicPr>
@@ -18311,7 +16537,7 @@
       </p:pic>
       <p:sp>
         <p:nvSpPr>
-          <p:cNvPr id="10" name="TextBox 9"/>
+          <p:cNvPr id="9" name="TextBox 8"/>
           <p:cNvSpPr txBox="1"/>
           <p:nvPr/>
         </p:nvSpPr>
@@ -18467,44 +16693,9 @@
           </a:fontRef>
         </p:style>
       </p:cxnSp>
-      <p:sp>
-        <p:nvSpPr>
-          <p:cNvPr id="5" name="TextBox 4"/>
-          <p:cNvSpPr txBox="1"/>
-          <p:nvPr/>
-        </p:nvSpPr>
-        <p:spPr>
-          <a:xfrm>
-            <a:off x="777240" y="1261872"/>
-            <a:ext cx="10607040" cy="310896"/>
-          </a:xfrm>
-          <a:prstGeom prst="rect">
-            <a:avLst/>
-          </a:prstGeom>
-          <a:noFill/>
-        </p:spPr>
-        <p:txBody>
-          <a:bodyPr wrap="square" lIns="45720" rIns="45720" tIns="18288" bIns="18288" anchor="t">
-            <a:spAutoFit/>
-          </a:bodyPr>
-          <a:lstStyle/>
-          <a:p>
-            <a:pPr algn="l"/>
-            <a:r>
-              <a:rPr sz="1700" b="0" i="1">
-                <a:solidFill>
-                  <a:srgbClr val="6B6B6B"/>
-                </a:solidFill>
-                <a:latin typeface="Century Schoolbook"/>
-              </a:rPr>
-              <a:t>Worked.</a:t>
-            </a:r>
-          </a:p>
-        </p:txBody>
-      </p:sp>
       <p:cxnSp>
         <p:nvCxnSpPr>
-          <p:cNvPr id="6" name="Connector 5"/>
+          <p:cNvPr id="5" name="Connector 4"/>
           <p:cNvCxnSpPr/>
           <p:nvPr/>
         </p:nvCxnSpPr>
@@ -18539,7 +16730,7 @@
       </p:cxnSp>
       <p:sp>
         <p:nvSpPr>
-          <p:cNvPr id="7" name="TextBox 6"/>
+          <p:cNvPr id="6" name="TextBox 5"/>
           <p:cNvSpPr txBox="1"/>
           <p:nvPr/>
         </p:nvSpPr>
@@ -18574,7 +16765,7 @@
       </p:sp>
       <p:sp>
         <p:nvSpPr>
-          <p:cNvPr id="8" name="TextBox 7"/>
+          <p:cNvPr id="7" name="TextBox 6"/>
           <p:cNvSpPr txBox="1"/>
           <p:nvPr/>
         </p:nvSpPr>
@@ -18609,7 +16800,7 @@
       </p:sp>
       <p:pic>
         <p:nvPicPr>
-          <p:cNvPr id="9" name="Picture 8" descr="8e941bf8846b5513.png"/>
+          <p:cNvPr id="8" name="Picture 7" descr="8e941bf8846b5513.png"/>
           <p:cNvPicPr>
             <a:picLocks noChangeAspect="1"/>
           </p:cNvPicPr>
@@ -18631,44 +16822,9 @@
           </a:prstGeom>
         </p:spPr>
       </p:pic>
-      <p:sp>
-        <p:nvSpPr>
-          <p:cNvPr id="10" name="TextBox 9"/>
-          <p:cNvSpPr txBox="1"/>
-          <p:nvPr/>
-        </p:nvSpPr>
-        <p:spPr>
-          <a:xfrm>
-            <a:off x="5084064" y="2037588"/>
-            <a:ext cx="6300215" cy="502920"/>
-          </a:xfrm>
-          <a:prstGeom prst="rect">
-            <a:avLst/>
-          </a:prstGeom>
-          <a:noFill/>
-        </p:spPr>
-        <p:txBody>
-          <a:bodyPr wrap="square" lIns="45720" rIns="45720" tIns="18288" bIns="18288" anchor="ctr">
-            <a:spAutoFit/>
-          </a:bodyPr>
-          <a:lstStyle/>
-          <a:p>
-            <a:pPr algn="l"/>
-            <a:r>
-              <a:rPr sz="2100" b="0" i="1">
-                <a:solidFill>
-                  <a:srgbClr val="6B6B6B"/>
-                </a:solidFill>
-                <a:latin typeface="Century Schoolbook"/>
-              </a:rPr>
-              <a:t>flip the base; the sign stays</a:t>
-            </a:r>
-          </a:p>
-        </p:txBody>
-      </p:sp>
       <p:pic>
         <p:nvPicPr>
-          <p:cNvPr id="11" name="Picture 10" descr="b75e3c313a78d69c.png"/>
+          <p:cNvPr id="9" name="Picture 8" descr="b75e3c313a78d69c.png"/>
           <p:cNvPicPr>
             <a:picLocks noChangeAspect="1"/>
           </p:cNvPicPr>
@@ -18692,42 +16848,7 @@
       </p:pic>
       <p:sp>
         <p:nvSpPr>
-          <p:cNvPr id="12" name="TextBox 11"/>
-          <p:cNvSpPr txBox="1"/>
-          <p:nvPr/>
-        </p:nvSpPr>
-        <p:spPr>
-          <a:xfrm>
-            <a:off x="4175760" y="3006852"/>
-            <a:ext cx="6400800" cy="502920"/>
-          </a:xfrm>
-          <a:prstGeom prst="rect">
-            <a:avLst/>
-          </a:prstGeom>
-          <a:noFill/>
-        </p:spPr>
-        <p:txBody>
-          <a:bodyPr wrap="square" lIns="45720" rIns="45720" tIns="18288" bIns="18288" anchor="ctr">
-            <a:spAutoFit/>
-          </a:bodyPr>
-          <a:lstStyle/>
-          <a:p>
-            <a:pPr algn="l"/>
-            <a:r>
-              <a:rPr sz="2100" b="0" i="1">
-                <a:solidFill>
-                  <a:srgbClr val="6B6B6B"/>
-                </a:solidFill>
-                <a:latin typeface="Century Schoolbook"/>
-              </a:rPr>
-              <a:t>even power: positive</a:t>
-            </a:r>
-          </a:p>
-        </p:txBody>
-      </p:sp>
-      <p:sp>
-        <p:nvSpPr>
-          <p:cNvPr id="13" name="TextBox 12"/>
+          <p:cNvPr id="10" name="TextBox 9"/>
           <p:cNvSpPr txBox="1"/>
           <p:nvPr/>
         </p:nvSpPr>
@@ -18883,44 +17004,9 @@
           </a:fontRef>
         </p:style>
       </p:cxnSp>
-      <p:sp>
-        <p:nvSpPr>
-          <p:cNvPr id="5" name="TextBox 4"/>
-          <p:cNvSpPr txBox="1"/>
-          <p:nvPr/>
-        </p:nvSpPr>
-        <p:spPr>
-          <a:xfrm>
-            <a:off x="777240" y="1261872"/>
-            <a:ext cx="10607040" cy="310896"/>
-          </a:xfrm>
-          <a:prstGeom prst="rect">
-            <a:avLst/>
-          </a:prstGeom>
-          <a:noFill/>
-        </p:spPr>
-        <p:txBody>
-          <a:bodyPr wrap="square" lIns="45720" rIns="45720" tIns="18288" bIns="18288" anchor="t">
-            <a:spAutoFit/>
-          </a:bodyPr>
-          <a:lstStyle/>
-          <a:p>
-            <a:pPr algn="l"/>
-            <a:r>
-              <a:rPr sz="1700" b="0" i="1">
-                <a:solidFill>
-                  <a:srgbClr val="6B6B6B"/>
-                </a:solidFill>
-                <a:latin typeface="Century Schoolbook"/>
-              </a:rPr>
-              <a:t>Same steps, your numbers. Boards up when done.</a:t>
-            </a:r>
-          </a:p>
-        </p:txBody>
-      </p:sp>
       <p:cxnSp>
         <p:nvCxnSpPr>
-          <p:cNvPr id="6" name="Connector 5"/>
+          <p:cNvPr id="5" name="Connector 4"/>
           <p:cNvCxnSpPr/>
           <p:nvPr/>
         </p:nvCxnSpPr>
@@ -18955,7 +17041,7 @@
       </p:cxnSp>
       <p:sp>
         <p:nvSpPr>
-          <p:cNvPr id="7" name="TextBox 6"/>
+          <p:cNvPr id="6" name="TextBox 5"/>
           <p:cNvSpPr txBox="1"/>
           <p:nvPr/>
         </p:nvSpPr>
@@ -18990,7 +17076,7 @@
       </p:sp>
       <p:sp>
         <p:nvSpPr>
-          <p:cNvPr id="8" name="TextBox 7"/>
+          <p:cNvPr id="7" name="TextBox 6"/>
           <p:cNvSpPr txBox="1"/>
           <p:nvPr/>
         </p:nvSpPr>
@@ -19025,7 +17111,7 @@
       </p:sp>
       <p:pic>
         <p:nvPicPr>
-          <p:cNvPr id="9" name="Picture 8" descr="a7f1f688f77ec613.png"/>
+          <p:cNvPr id="8" name="Picture 7" descr="a7f1f688f77ec613.png"/>
           <p:cNvPicPr>
             <a:picLocks noChangeAspect="1"/>
           </p:cNvPicPr>
@@ -19047,6 +17133,41 @@
           </a:prstGeom>
         </p:spPr>
       </p:pic>
+      <p:sp>
+        <p:nvSpPr>
+          <p:cNvPr id="9" name="TextBox 8"/>
+          <p:cNvSpPr txBox="1"/>
+          <p:nvPr/>
+        </p:nvSpPr>
+        <p:spPr>
+          <a:xfrm>
+            <a:off x="777240" y="3560064"/>
+            <a:ext cx="10607040" cy="429370"/>
+          </a:xfrm>
+          <a:prstGeom prst="rect">
+            <a:avLst/>
+          </a:prstGeom>
+          <a:noFill/>
+        </p:spPr>
+        <p:txBody>
+          <a:bodyPr wrap="square" lIns="45720" rIns="45720" tIns="18288" bIns="18288" anchor="t">
+            <a:spAutoFit/>
+          </a:bodyPr>
+          <a:lstStyle/>
+          <a:p>
+            <a:pPr algn="ctr"/>
+            <a:r>
+              <a:rPr sz="2400" b="1" i="0">
+                <a:solidFill>
+                  <a:srgbClr val="1A1A1A"/>
+                </a:solidFill>
+                <a:latin typeface="Century Schoolbook"/>
+              </a:rPr>
+              <a:t>Rewrite with a positive exponent, then find the value.</a:t>
+            </a:r>
+          </a:p>
+        </p:txBody>
+      </p:sp>
     </p:spTree>
   </p:cSld>
   <p:clrMapOvr>

</xml_diff>